<commit_message>
docs: incorporar imagens de alta resolucao das formulas latex na apresentacao e manual
</commit_message>
<xml_diff>
--- a/docs/Apresentacao_SAREL_PPGTCA_2026.pptx
+++ b/docs/Apresentacao_SAREL_PPGTCA_2026.pptx
@@ -21,6 +21,7 @@
     <p:sldId id="269" r:id="rId20"/>
     <p:sldId id="270" r:id="rId21"/>
     <p:sldId id="271" r:id="rId22"/>
+    <p:sldId id="272" r:id="rId23"/>
   </p:sldIdLst>
   <p:sldSz cx="12191695" cy="6858000" type="screen4x3"/>
   <p:notesSz cx="6858000" cy="9144000"/>
@@ -3380,7 +3381,7 @@
               </a:defRPr>
             </a:pPr>
             <a:r>
-              <a:t>9. Cálculos Matemáticos: Índices Espectrais e Fenologia</a:t>
+              <a:t>9. Síntese Visual das Formulações Matemáticas Canônicas do SAREL</a:t>
             </a:r>
           </a:p>
         </p:txBody>
@@ -3465,446 +3466,30 @@
           </a:p>
         </p:txBody>
       </p:sp>
-      <p:sp>
-        <p:nvSpPr>
-          <p:cNvPr id="7" name="Rounded Rectangle 6"/>
-          <p:cNvSpPr/>
-          <p:nvPr/>
-        </p:nvSpPr>
-        <p:spPr>
-          <a:xfrm>
-            <a:off x="731520" y="1371600"/>
-            <a:ext cx="5257800" cy="2240280"/>
-          </a:xfrm>
-          <a:prstGeom prst="roundRect">
-            <a:avLst/>
-          </a:prstGeom>
-          <a:solidFill>
-            <a:srgbClr val="FFFFFF"/>
-          </a:solidFill>
-          <a:ln>
-            <a:solidFill>
-              <a:srgbClr val="E2E8F0"/>
-            </a:solidFill>
-          </a:ln>
-        </p:spPr>
-        <p:style>
-          <a:lnRef idx="1">
-            <a:schemeClr val="accent1"/>
-          </a:lnRef>
-          <a:fillRef idx="3">
-            <a:schemeClr val="accent1"/>
-          </a:fillRef>
-          <a:effectRef idx="2">
-            <a:schemeClr val="accent1"/>
-          </a:effectRef>
-          <a:fontRef idx="minor">
-            <a:schemeClr val="lt1"/>
-          </a:fontRef>
-        </p:style>
-        <p:txBody>
-          <a:bodyPr rtlCol="0" anchor="ctr"/>
-          <a:lstStyle/>
-          <a:p>
-            <a:pPr algn="ctr"/>
-          </a:p>
-        </p:txBody>
-      </p:sp>
-      <p:sp>
-        <p:nvSpPr>
-          <p:cNvPr id="8" name="TextBox 7"/>
-          <p:cNvSpPr txBox="1"/>
-          <p:nvPr/>
-        </p:nvSpPr>
-        <p:spPr>
-          <a:xfrm>
-            <a:off x="914400" y="1508760"/>
-            <a:ext cx="4892040" cy="1965960"/>
-          </a:xfrm>
-          <a:prstGeom prst="rect">
-            <a:avLst/>
-          </a:prstGeom>
-          <a:noFill/>
-        </p:spPr>
-        <p:txBody>
-          <a:bodyPr wrap="square">
-            <a:spAutoFit/>
-          </a:bodyPr>
-          <a:lstStyle/>
-          <a:p>
-            <a:pPr>
-              <a:spcAft>
-                <a:spcPts val="400"/>
-              </a:spcAft>
-              <a:defRPr b="1" sz="1150">
-                <a:solidFill>
-                  <a:srgbClr val="0F172A"/>
-                </a:solidFill>
-              </a:defRPr>
-            </a:pPr>
-            <a:r>
-              <a:t>1. Índice de Vegetação por Diferença Normalizada (NDVI)</a:t>
-            </a:r>
-          </a:p>
-          <a:p>
-            <a:pPr>
-              <a:spcAft>
-                <a:spcPts val="600"/>
-              </a:spcAft>
-              <a:defRPr b="1" sz="1100">
-                <a:solidFill>
-                  <a:srgbClr val="065F46"/>
-                </a:solidFill>
-              </a:defRPr>
-            </a:pPr>
-            <a:r>
-              <a:t>NDVI = (B8 - B4) / (B8 + B4)</a:t>
-            </a:r>
-          </a:p>
-          <a:p>
-            <a:pPr>
-              <a:defRPr sz="950">
-                <a:solidFill>
-                  <a:srgbClr val="0F172A"/>
-                </a:solidFill>
-              </a:defRPr>
-            </a:pPr>
-            <a:r>
-              <a:t>Mede o vigor fotossintético da biomassa vegetal ativa. Varia de -1 a +1. Banda B8 (Infravermelho Próximo) e Banda B4 (Vermelho). Base seminal: Rouse et al. (1974).</a:t>
-            </a:r>
-          </a:p>
-        </p:txBody>
-      </p:sp>
-      <p:sp>
-        <p:nvSpPr>
-          <p:cNvPr id="9" name="Rounded Rectangle 8"/>
-          <p:cNvSpPr/>
-          <p:nvPr/>
-        </p:nvSpPr>
-        <p:spPr>
-          <a:xfrm>
-            <a:off x="6172200" y="1371600"/>
-            <a:ext cx="5257800" cy="2240280"/>
-          </a:xfrm>
-          <a:prstGeom prst="roundRect">
-            <a:avLst/>
-          </a:prstGeom>
-          <a:solidFill>
-            <a:srgbClr val="FFFFFF"/>
-          </a:solidFill>
-          <a:ln>
-            <a:solidFill>
-              <a:srgbClr val="E2E8F0"/>
-            </a:solidFill>
-          </a:ln>
-        </p:spPr>
-        <p:style>
-          <a:lnRef idx="1">
-            <a:schemeClr val="accent1"/>
-          </a:lnRef>
-          <a:fillRef idx="3">
-            <a:schemeClr val="accent1"/>
-          </a:fillRef>
-          <a:effectRef idx="2">
-            <a:schemeClr val="accent1"/>
-          </a:effectRef>
-          <a:fontRef idx="minor">
-            <a:schemeClr val="lt1"/>
-          </a:fontRef>
-        </p:style>
-        <p:txBody>
-          <a:bodyPr rtlCol="0" anchor="ctr"/>
-          <a:lstStyle/>
-          <a:p>
-            <a:pPr algn="ctr"/>
-          </a:p>
-        </p:txBody>
-      </p:sp>
-      <p:sp>
-        <p:nvSpPr>
-          <p:cNvPr id="10" name="TextBox 9"/>
-          <p:cNvSpPr txBox="1"/>
-          <p:nvPr/>
-        </p:nvSpPr>
-        <p:spPr>
-          <a:xfrm>
-            <a:off x="6355080" y="1508760"/>
-            <a:ext cx="4892040" cy="1965960"/>
-          </a:xfrm>
-          <a:prstGeom prst="rect">
-            <a:avLst/>
-          </a:prstGeom>
-          <a:noFill/>
-        </p:spPr>
-        <p:txBody>
-          <a:bodyPr wrap="square">
-            <a:spAutoFit/>
-          </a:bodyPr>
-          <a:lstStyle/>
-          <a:p>
-            <a:pPr>
-              <a:spcAft>
-                <a:spcPts val="400"/>
-              </a:spcAft>
-              <a:defRPr b="1" sz="1150">
-                <a:solidFill>
-                  <a:srgbClr val="0F172A"/>
-                </a:solidFill>
-              </a:defRPr>
-            </a:pPr>
-            <a:r>
-              <a:t>2. Índice de Solo Exposto (Bare Soil Index - BSI)</a:t>
-            </a:r>
-          </a:p>
-          <a:p>
-            <a:pPr>
-              <a:spcAft>
-                <a:spcPts val="600"/>
-              </a:spcAft>
-              <a:defRPr b="1" sz="1100">
-                <a:solidFill>
-                  <a:srgbClr val="065F46"/>
-                </a:solidFill>
-              </a:defRPr>
-            </a:pPr>
-            <a:r>
-              <a:t>BSI = [(B11 + B4) - (B8 + B2)] / [(B11 + B4) + (B8 + B2)]</a:t>
-            </a:r>
-          </a:p>
-          <a:p>
-            <a:pPr>
-              <a:defRPr sz="950">
-                <a:solidFill>
-                  <a:srgbClr val="0F172A"/>
-                </a:solidFill>
-              </a:defRPr>
-            </a:pPr>
-            <a:r>
-              <a:t>Discrimina solo mineralizado desnudo de cobertura vegetal densa. Valores positivos (&gt; 0.10) associam-se a solo descoberto ou horizonte B exposto (Rikimaru et al., 2002).</a:t>
-            </a:r>
-          </a:p>
-        </p:txBody>
-      </p:sp>
-      <p:sp>
-        <p:nvSpPr>
-          <p:cNvPr id="11" name="Rounded Rectangle 10"/>
-          <p:cNvSpPr/>
-          <p:nvPr/>
-        </p:nvSpPr>
-        <p:spPr>
-          <a:xfrm>
-            <a:off x="731520" y="3840480"/>
-            <a:ext cx="5257800" cy="2240280"/>
-          </a:xfrm>
-          <a:prstGeom prst="roundRect">
-            <a:avLst/>
-          </a:prstGeom>
-          <a:solidFill>
-            <a:srgbClr val="FFFFFF"/>
-          </a:solidFill>
-          <a:ln>
-            <a:solidFill>
-              <a:srgbClr val="E2E8F0"/>
-            </a:solidFill>
-          </a:ln>
-        </p:spPr>
-        <p:style>
-          <a:lnRef idx="1">
-            <a:schemeClr val="accent1"/>
-          </a:lnRef>
-          <a:fillRef idx="3">
-            <a:schemeClr val="accent1"/>
-          </a:fillRef>
-          <a:effectRef idx="2">
-            <a:schemeClr val="accent1"/>
-          </a:effectRef>
-          <a:fontRef idx="minor">
-            <a:schemeClr val="lt1"/>
-          </a:fontRef>
-        </p:style>
-        <p:txBody>
-          <a:bodyPr rtlCol="0" anchor="ctr"/>
-          <a:lstStyle/>
-          <a:p>
-            <a:pPr algn="ctr"/>
-          </a:p>
-        </p:txBody>
-      </p:sp>
-      <p:sp>
-        <p:nvSpPr>
-          <p:cNvPr id="12" name="TextBox 11"/>
-          <p:cNvSpPr txBox="1"/>
-          <p:nvPr/>
-        </p:nvSpPr>
-        <p:spPr>
-          <a:xfrm>
-            <a:off x="914400" y="3977640"/>
-            <a:ext cx="4892040" cy="1965960"/>
-          </a:xfrm>
-          <a:prstGeom prst="rect">
-            <a:avLst/>
-          </a:prstGeom>
-          <a:noFill/>
-        </p:spPr>
-        <p:txBody>
-          <a:bodyPr wrap="square">
-            <a:spAutoFit/>
-          </a:bodyPr>
-          <a:lstStyle/>
-          <a:p>
-            <a:pPr>
-              <a:spcAft>
-                <a:spcPts val="400"/>
-              </a:spcAft>
-              <a:defRPr b="1" sz="1150">
-                <a:solidFill>
-                  <a:srgbClr val="0F172A"/>
-                </a:solidFill>
-              </a:defRPr>
-            </a:pPr>
-            <a:r>
-              <a:t>3. Decomposição Harmônica OLS (Zhu &amp; Woodcock, 2014)</a:t>
-            </a:r>
-          </a:p>
-          <a:p>
-            <a:pPr>
-              <a:spcAft>
-                <a:spcPts val="600"/>
-              </a:spcAft>
-              <a:defRPr b="1" sz="1100">
-                <a:solidFill>
-                  <a:srgbClr val="065F46"/>
-                </a:solidFill>
-              </a:defRPr>
-            </a:pPr>
-            <a:r>
-              <a:t>y^(t) = c0 + c1·t + SUM_{k=1..m} [ak·cos(2·pi·k·t / T) + bk·sen(2·pi·k·t / T)]</a:t>
-            </a:r>
-          </a:p>
-          <a:p>
-            <a:pPr>
-              <a:defRPr sz="950">
-                <a:solidFill>
-                  <a:srgbClr val="0F172A"/>
-                </a:solidFill>
-              </a:defRPr>
-            </a:pPr>
-            <a:r>
-              <a:t>Modela a sazonalidade fenológica regular e estima a taxa de degradação linear (c1) no SWIR B12, separando ciclos agrícolas de erosão progressiva.</a:t>
-            </a:r>
-          </a:p>
-        </p:txBody>
-      </p:sp>
-      <p:sp>
-        <p:nvSpPr>
-          <p:cNvPr id="13" name="Rounded Rectangle 12"/>
-          <p:cNvSpPr/>
-          <p:nvPr/>
-        </p:nvSpPr>
-        <p:spPr>
-          <a:xfrm>
-            <a:off x="6172200" y="3840480"/>
-            <a:ext cx="5257800" cy="2240280"/>
-          </a:xfrm>
-          <a:prstGeom prst="roundRect">
-            <a:avLst/>
-          </a:prstGeom>
-          <a:solidFill>
-            <a:srgbClr val="FFFFFF"/>
-          </a:solidFill>
-          <a:ln>
-            <a:solidFill>
-              <a:srgbClr val="E2E8F0"/>
-            </a:solidFill>
-          </a:ln>
-        </p:spPr>
-        <p:style>
-          <a:lnRef idx="1">
-            <a:schemeClr val="accent1"/>
-          </a:lnRef>
-          <a:fillRef idx="3">
-            <a:schemeClr val="accent1"/>
-          </a:fillRef>
-          <a:effectRef idx="2">
-            <a:schemeClr val="accent1"/>
-          </a:effectRef>
-          <a:fontRef idx="minor">
-            <a:schemeClr val="lt1"/>
-          </a:fontRef>
-        </p:style>
-        <p:txBody>
-          <a:bodyPr rtlCol="0" anchor="ctr"/>
-          <a:lstStyle/>
-          <a:p>
-            <a:pPr algn="ctr"/>
-          </a:p>
-        </p:txBody>
-      </p:sp>
-      <p:sp>
-        <p:nvSpPr>
-          <p:cNvPr id="14" name="TextBox 13"/>
-          <p:cNvSpPr txBox="1"/>
-          <p:nvPr/>
-        </p:nvSpPr>
-        <p:spPr>
-          <a:xfrm>
-            <a:off x="6355080" y="3977640"/>
-            <a:ext cx="4892040" cy="1965960"/>
-          </a:xfrm>
-          <a:prstGeom prst="rect">
-            <a:avLst/>
-          </a:prstGeom>
-          <a:noFill/>
-        </p:spPr>
-        <p:txBody>
-          <a:bodyPr wrap="square">
-            <a:spAutoFit/>
-          </a:bodyPr>
-          <a:lstStyle/>
-          <a:p>
-            <a:pPr>
-              <a:spcAft>
-                <a:spcPts val="400"/>
-              </a:spcAft>
-              <a:defRPr b="1" sz="1150">
-                <a:solidFill>
-                  <a:srgbClr val="0F172A"/>
-                </a:solidFill>
-              </a:defRPr>
-            </a:pPr>
-            <a:r>
-              <a:t>4. Frequência de Solo Nu (E^) — Decisão D10 (GEOS3)</a:t>
-            </a:r>
-          </a:p>
-          <a:p>
-            <a:pPr>
-              <a:spcAft>
-                <a:spcPts val="600"/>
-              </a:spcAft>
-              <a:defRPr b="1" sz="1100">
-                <a:solidFill>
-                  <a:srgbClr val="065F46"/>
-                </a:solidFill>
-              </a:defRPr>
-            </a:pPr>
-            <a:r>
-              <a:t>E^ = (1 / N_valido) * SUM_{i=1..N} I(NDVI_i &lt;= 0.25)</a:t>
-            </a:r>
-          </a:p>
-          <a:p>
-            <a:pPr>
-              <a:defRPr sz="950">
-                <a:solidFill>
-                  <a:srgbClr val="0F172A"/>
-                </a:solidFill>
-              </a:defRPr>
-            </a:pPr>
-            <a:r>
-              <a:t>Fração temporal em que o solo permanece exposto ao impacto de chuva torrencial. Calibrado pelo sistema GEOS3 (Demattê et al., 2018; Safanelli et al., 2021).</a:t>
-            </a:r>
-          </a:p>
-        </p:txBody>
-      </p:sp>
+      <p:pic>
+        <p:nvPicPr>
+          <p:cNvPr id="7" name="Picture 6" descr="quadro_completo_formulas.png"/>
+          <p:cNvPicPr>
+            <a:picLocks noChangeAspect="1"/>
+          </p:cNvPicPr>
+          <p:nvPr/>
+        </p:nvPicPr>
+        <p:blipFill>
+          <a:blip r:embed="rId2"/>
+          <a:stretch>
+            <a:fillRect/>
+          </a:stretch>
+        </p:blipFill>
+        <p:spPr>
+          <a:xfrm>
+            <a:off x="868680" y="1234440"/>
+            <a:ext cx="10454335" cy="5975294"/>
+          </a:xfrm>
+          <a:prstGeom prst="rect">
+            <a:avLst/>
+          </a:prstGeom>
+        </p:spPr>
+      </p:pic>
     </p:spTree>
   </p:cSld>
   <p:clrMapOvr>
@@ -4041,7 +3626,7 @@
               </a:defRPr>
             </a:pPr>
             <a:r>
-              <a:t>10. Cálculos Matemáticos: Fatores RUSLE e Dinâmica G2</a:t>
+              <a:t>10. Cálculos Matemáticos: Índices Espectrais e Fenologia</a:t>
             </a:r>
           </a:p>
         </p:txBody>
@@ -4134,8 +3719,8 @@
         </p:nvSpPr>
         <p:spPr>
           <a:xfrm>
-            <a:off x="731520" y="1371600"/>
-            <a:ext cx="5257800" cy="2240280"/>
+            <a:off x="731520" y="1280160"/>
+            <a:ext cx="5257800" cy="2423160"/>
           </a:xfrm>
           <a:prstGeom prst="roundRect">
             <a:avLst/>
@@ -4179,8 +3764,8 @@
         </p:nvSpPr>
         <p:spPr>
           <a:xfrm>
-            <a:off x="914400" y="1508760"/>
-            <a:ext cx="4892040" cy="1965960"/>
+            <a:off x="914400" y="1389888"/>
+            <a:ext cx="4892040" cy="365760"/>
           </a:xfrm>
           <a:prstGeom prst="rect">
             <a:avLst/>
@@ -4194,58 +3779,87 @@
           <a:lstStyle/>
           <a:p>
             <a:pPr>
-              <a:spcAft>
-                <a:spcPts val="400"/>
-              </a:spcAft>
-              <a:defRPr b="1" sz="1150">
+              <a:defRPr b="1" sz="1100">
                 <a:solidFill>
                   <a:srgbClr val="0F172A"/>
                 </a:solidFill>
               </a:defRPr>
             </a:pPr>
             <a:r>
-              <a:t>5. Fator C da RUSLE Regional Tropical (Decisão D01)</a:t>
-            </a:r>
-          </a:p>
-          <a:p>
-            <a:pPr>
-              <a:spcAft>
-                <a:spcPts val="600"/>
-              </a:spcAft>
-              <a:defRPr b="1" sz="1050">
-                <a:solidFill>
-                  <a:srgbClr val="065F46"/>
-                </a:solidFill>
-              </a:defRPr>
-            </a:pPr>
-            <a:r>
-              <a:t>C = [(1 - NDVI) / 2]^(1 + NDVI)</a:t>
-            </a:r>
-          </a:p>
-          <a:p>
-            <a:pPr>
-              <a:defRPr sz="950">
+              <a:t>1. Índice de Vegetação por Diferença Normalizada (NDVI)</a:t>
+            </a:r>
+          </a:p>
+        </p:txBody>
+      </p:sp>
+      <p:pic>
+        <p:nvPicPr>
+          <p:cNvPr id="9" name="Picture 8" descr="formula_01_ndvi.png"/>
+          <p:cNvPicPr>
+            <a:picLocks noChangeAspect="1"/>
+          </p:cNvPicPr>
+          <p:nvPr/>
+        </p:nvPicPr>
+        <p:blipFill>
+          <a:blip r:embed="rId2"/>
+          <a:stretch>
+            <a:fillRect/>
+          </a:stretch>
+        </p:blipFill>
+        <p:spPr>
+          <a:xfrm>
+            <a:off x="960120" y="1783080"/>
+            <a:ext cx="2254015" cy="457200"/>
+          </a:xfrm>
+          <a:prstGeom prst="rect">
+            <a:avLst/>
+          </a:prstGeom>
+        </p:spPr>
+      </p:pic>
+      <p:sp>
+        <p:nvSpPr>
+          <p:cNvPr id="10" name="TextBox 9"/>
+          <p:cNvSpPr txBox="1"/>
+          <p:nvPr/>
+        </p:nvSpPr>
+        <p:spPr>
+          <a:xfrm>
+            <a:off x="914400" y="2331720"/>
+            <a:ext cx="4892040" cy="1280160"/>
+          </a:xfrm>
+          <a:prstGeom prst="rect">
+            <a:avLst/>
+          </a:prstGeom>
+          <a:noFill/>
+        </p:spPr>
+        <p:txBody>
+          <a:bodyPr wrap="square">
+            <a:spAutoFit/>
+          </a:bodyPr>
+          <a:lstStyle/>
+          <a:p>
+            <a:pPr>
+              <a:defRPr sz="919">
                 <a:solidFill>
                   <a:srgbClr val="0F172A"/>
                 </a:solidFill>
               </a:defRPr>
             </a:pPr>
             <a:r>
-              <a:t>Modelo calibrado para bacias brasileiras por Durigon et al. (2014). Para solo nu (NDVI = 0.0), C = 0.50; para vegetação densa (NDVI = 0.80), C = 0.026. Evita subestimação.</a:t>
-            </a:r>
-          </a:p>
-        </p:txBody>
-      </p:sp>
-      <p:sp>
-        <p:nvSpPr>
-          <p:cNvPr id="9" name="Rounded Rectangle 8"/>
+              <a:t>Mede o vigor fotossintético da biomassa vegetal ativa. Varia de -1 a +1. Banda B8 (NIR) e Banda B4 (Vermelho). Base seminal: Rouse et al. (1974).</a:t>
+            </a:r>
+          </a:p>
+        </p:txBody>
+      </p:sp>
+      <p:sp>
+        <p:nvSpPr>
+          <p:cNvPr id="11" name="Rounded Rectangle 10"/>
           <p:cNvSpPr/>
           <p:nvPr/>
         </p:nvSpPr>
         <p:spPr>
           <a:xfrm>
-            <a:off x="6172200" y="1371600"/>
-            <a:ext cx="5257800" cy="2240280"/>
+            <a:off x="6172200" y="1280160"/>
+            <a:ext cx="5257800" cy="2423160"/>
           </a:xfrm>
           <a:prstGeom prst="roundRect">
             <a:avLst/>
@@ -4283,14 +3897,14 @@
       </p:sp>
       <p:sp>
         <p:nvSpPr>
-          <p:cNvPr id="10" name="TextBox 9"/>
+          <p:cNvPr id="12" name="TextBox 11"/>
           <p:cNvSpPr txBox="1"/>
           <p:nvPr/>
         </p:nvSpPr>
         <p:spPr>
           <a:xfrm>
-            <a:off x="6355080" y="1508760"/>
-            <a:ext cx="4892040" cy="1965960"/>
+            <a:off x="6355080" y="1389888"/>
+            <a:ext cx="4892040" cy="365760"/>
           </a:xfrm>
           <a:prstGeom prst="rect">
             <a:avLst/>
@@ -4304,58 +3918,87 @@
           <a:lstStyle/>
           <a:p>
             <a:pPr>
-              <a:spcAft>
-                <a:spcPts val="400"/>
-              </a:spcAft>
-              <a:defRPr b="1" sz="1150">
+              <a:defRPr b="1" sz="1100">
                 <a:solidFill>
                   <a:srgbClr val="0F172A"/>
                 </a:solidFill>
               </a:defRPr>
             </a:pPr>
             <a:r>
-              <a:t>6. Fator K Numérico (Tabela 5 Embrapa Solos / D14)</a:t>
-            </a:r>
-          </a:p>
-          <a:p>
-            <a:pPr>
-              <a:spcAft>
-                <a:spcPts val="600"/>
-              </a:spcAft>
-              <a:defRPr b="1" sz="1050">
-                <a:solidFill>
-                  <a:srgbClr val="065F46"/>
-                </a:solidFill>
-              </a:defRPr>
-            </a:pPr>
-            <a:r>
-              <a:t>K = [0.0052; 0.0117; 0.0218; 0.0360; 0.0518] t·h/(MJ·mm)</a:t>
-            </a:r>
-          </a:p>
-          <a:p>
-            <a:pPr>
-              <a:defRPr sz="950">
+              <a:t>2. Índice de Solo Exposto (Bare Soil Index - BSI)</a:t>
+            </a:r>
+          </a:p>
+        </p:txBody>
+      </p:sp>
+      <p:pic>
+        <p:nvPicPr>
+          <p:cNvPr id="13" name="Picture 12" descr="formula_02_bsi.png"/>
+          <p:cNvPicPr>
+            <a:picLocks noChangeAspect="1"/>
+          </p:cNvPicPr>
+          <p:nvPr/>
+        </p:nvPicPr>
+        <p:blipFill>
+          <a:blip r:embed="rId3"/>
+          <a:stretch>
+            <a:fillRect/>
+          </a:stretch>
+        </p:blipFill>
+        <p:spPr>
+          <a:xfrm>
+            <a:off x="6400800" y="1783080"/>
+            <a:ext cx="2648174" cy="457200"/>
+          </a:xfrm>
+          <a:prstGeom prst="rect">
+            <a:avLst/>
+          </a:prstGeom>
+        </p:spPr>
+      </p:pic>
+      <p:sp>
+        <p:nvSpPr>
+          <p:cNvPr id="14" name="TextBox 13"/>
+          <p:cNvSpPr txBox="1"/>
+          <p:nvPr/>
+        </p:nvSpPr>
+        <p:spPr>
+          <a:xfrm>
+            <a:off x="6355080" y="2331720"/>
+            <a:ext cx="4892040" cy="1280160"/>
+          </a:xfrm>
+          <a:prstGeom prst="rect">
+            <a:avLst/>
+          </a:prstGeom>
+          <a:noFill/>
+        </p:spPr>
+        <p:txBody>
+          <a:bodyPr wrap="square">
+            <a:spAutoFit/>
+          </a:bodyPr>
+          <a:lstStyle/>
+          <a:p>
+            <a:pPr>
+              <a:defRPr sz="919">
                 <a:solidFill>
                   <a:srgbClr val="0F172A"/>
                 </a:solidFill>
               </a:defRPr>
             </a:pPr>
             <a:r>
-              <a:t>Conversão oficial da carta pedológica para valores numéricos contínuos (Doc. 246/2024 / Mannigel et al., 2002). Estratificação K^: Nível 1 &lt;= 0.0285; Nível 2 &gt;= 0.0300 (D09).</a:t>
-            </a:r>
-          </a:p>
-        </p:txBody>
-      </p:sp>
-      <p:sp>
-        <p:nvSpPr>
-          <p:cNvPr id="11" name="Rounded Rectangle 10"/>
+              <a:t>Discrimina solo mineralizado desnudo de cobertura vegetal densa. Valores positivos (&gt; 0.10) associam-se a solo descoberto ou horizonte B exposto (Rikimaru et al., 2002).</a:t>
+            </a:r>
+          </a:p>
+        </p:txBody>
+      </p:sp>
+      <p:sp>
+        <p:nvSpPr>
+          <p:cNvPr id="15" name="Rounded Rectangle 14"/>
           <p:cNvSpPr/>
           <p:nvPr/>
         </p:nvSpPr>
         <p:spPr>
           <a:xfrm>
-            <a:off x="731520" y="3840480"/>
-            <a:ext cx="5257800" cy="2240280"/>
+            <a:off x="731520" y="3840479"/>
+            <a:ext cx="5257800" cy="2423160"/>
           </a:xfrm>
           <a:prstGeom prst="roundRect">
             <a:avLst/>
@@ -4393,14 +4036,14 @@
       </p:sp>
       <p:sp>
         <p:nvSpPr>
-          <p:cNvPr id="12" name="TextBox 11"/>
+          <p:cNvPr id="16" name="TextBox 15"/>
           <p:cNvSpPr txBox="1"/>
           <p:nvPr/>
         </p:nvSpPr>
         <p:spPr>
           <a:xfrm>
-            <a:off x="914400" y="3977640"/>
-            <a:ext cx="4892040" cy="1965960"/>
+            <a:off x="914400" y="3950207"/>
+            <a:ext cx="4892040" cy="365760"/>
           </a:xfrm>
           <a:prstGeom prst="rect">
             <a:avLst/>
@@ -4414,58 +4057,87 @@
           <a:lstStyle/>
           <a:p>
             <a:pPr>
-              <a:spcAft>
-                <a:spcPts val="400"/>
-              </a:spcAft>
-              <a:defRPr b="1" sz="1150">
+              <a:defRPr b="1" sz="1100">
                 <a:solidFill>
                   <a:srgbClr val="0F172A"/>
                 </a:solidFill>
               </a:defRPr>
             </a:pPr>
             <a:r>
-              <a:t>7. Equação de Perda de Solo (RUSLE)</a:t>
-            </a:r>
-          </a:p>
-          <a:p>
-            <a:pPr>
-              <a:spcAft>
-                <a:spcPts val="600"/>
-              </a:spcAft>
-              <a:defRPr b="1" sz="1050">
-                <a:solidFill>
-                  <a:srgbClr val="065F46"/>
-                </a:solidFill>
-              </a:defRPr>
-            </a:pPr>
-            <a:r>
-              <a:t>A = R * K * LS * C * P  (t/ha/ano)</a:t>
-            </a:r>
-          </a:p>
-          <a:p>
-            <a:pPr>
-              <a:defRPr sz="950">
+              <a:t>3. Decomposição Harmônica OLS (Zhu &amp; Woodcock, 2014)</a:t>
+            </a:r>
+          </a:p>
+        </p:txBody>
+      </p:sp>
+      <p:pic>
+        <p:nvPicPr>
+          <p:cNvPr id="17" name="Picture 16" descr="formula_03_harmonicos.png"/>
+          <p:cNvPicPr>
+            <a:picLocks noChangeAspect="1"/>
+          </p:cNvPicPr>
+          <p:nvPr/>
+        </p:nvPicPr>
+        <p:blipFill>
+          <a:blip r:embed="rId4"/>
+          <a:stretch>
+            <a:fillRect/>
+          </a:stretch>
+        </p:blipFill>
+        <p:spPr>
+          <a:xfrm>
+            <a:off x="960120" y="4343399"/>
+            <a:ext cx="3040873" cy="457200"/>
+          </a:xfrm>
+          <a:prstGeom prst="rect">
+            <a:avLst/>
+          </a:prstGeom>
+        </p:spPr>
+      </p:pic>
+      <p:sp>
+        <p:nvSpPr>
+          <p:cNvPr id="18" name="TextBox 17"/>
+          <p:cNvSpPr txBox="1"/>
+          <p:nvPr/>
+        </p:nvSpPr>
+        <p:spPr>
+          <a:xfrm>
+            <a:off x="914400" y="4892039"/>
+            <a:ext cx="4892040" cy="1280160"/>
+          </a:xfrm>
+          <a:prstGeom prst="rect">
+            <a:avLst/>
+          </a:prstGeom>
+          <a:noFill/>
+        </p:spPr>
+        <p:txBody>
+          <a:bodyPr wrap="square">
+            <a:spAutoFit/>
+          </a:bodyPr>
+          <a:lstStyle/>
+          <a:p>
+            <a:pPr>
+              <a:defRPr sz="919">
                 <a:solidFill>
                   <a:srgbClr val="0F172A"/>
                 </a:solidFill>
               </a:defRPr>
             </a:pPr>
             <a:r>
-              <a:t>Equação Universal de Perda de Solo Revisada (Renard et al., 1997). Invariante 1: só calculada se os 5 fatores e a memória de cálculo existirem simultaneamente.</a:t>
-            </a:r>
-          </a:p>
-        </p:txBody>
-      </p:sp>
-      <p:sp>
-        <p:nvSpPr>
-          <p:cNvPr id="13" name="Rounded Rectangle 12"/>
+              <a:t>Modela a sazonalidade fenológica regular e estima a taxa de degradação linear (c1) no SWIR B12, separando ciclos agrícolas de erosão progressiva.</a:t>
+            </a:r>
+          </a:p>
+        </p:txBody>
+      </p:sp>
+      <p:sp>
+        <p:nvSpPr>
+          <p:cNvPr id="19" name="Rounded Rectangle 18"/>
           <p:cNvSpPr/>
           <p:nvPr/>
         </p:nvSpPr>
         <p:spPr>
           <a:xfrm>
-            <a:off x="6172200" y="3840480"/>
-            <a:ext cx="5257800" cy="2240280"/>
+            <a:off x="6172200" y="3840479"/>
+            <a:ext cx="5257800" cy="2423160"/>
           </a:xfrm>
           <a:prstGeom prst="roundRect">
             <a:avLst/>
@@ -4503,14 +4175,14 @@
       </p:sp>
       <p:sp>
         <p:nvSpPr>
-          <p:cNvPr id="14" name="TextBox 13"/>
+          <p:cNvPr id="20" name="TextBox 19"/>
           <p:cNvSpPr txBox="1"/>
           <p:nvPr/>
         </p:nvSpPr>
         <p:spPr>
           <a:xfrm>
-            <a:off x="6355080" y="3977640"/>
-            <a:ext cx="4892040" cy="1965960"/>
+            <a:off x="6355080" y="3950207"/>
+            <a:ext cx="4892040" cy="365760"/>
           </a:xfrm>
           <a:prstGeom prst="rect">
             <a:avLst/>
@@ -4524,44 +4196,73 @@
           <a:lstStyle/>
           <a:p>
             <a:pPr>
-              <a:spcAft>
-                <a:spcPts val="400"/>
-              </a:spcAft>
-              <a:defRPr b="1" sz="1150">
+              <a:defRPr b="1" sz="1100">
                 <a:solidFill>
                   <a:srgbClr val="0F172A"/>
                 </a:solidFill>
               </a:defRPr>
             </a:pPr>
             <a:r>
-              <a:t>8. Índice Dinâmico Chuva-Solo Nu (Modelo G2)</a:t>
-            </a:r>
-          </a:p>
-          <a:p>
-            <a:pPr>
-              <a:spcAft>
-                <a:spcPts val="600"/>
-              </a:spcAft>
-              <a:defRPr b="1" sz="1050">
-                <a:solidFill>
-                  <a:srgbClr val="065F46"/>
-                </a:solidFill>
-              </a:defRPr>
-            </a:pPr>
-            <a:r>
-              <a:t>I_mecanismo = SUM_t [ R_t * I(NDVI_t &lt;= 0.25) ]</a:t>
-            </a:r>
-          </a:p>
-          <a:p>
-            <a:pPr>
-              <a:defRPr sz="950">
+              <a:t>4. Frequência de Solo Nu (E^) — Decisão D10 (GEOS3)</a:t>
+            </a:r>
+          </a:p>
+        </p:txBody>
+      </p:sp>
+      <p:pic>
+        <p:nvPicPr>
+          <p:cNvPr id="21" name="Picture 20" descr="formula_04_solo_nu.png"/>
+          <p:cNvPicPr>
+            <a:picLocks noChangeAspect="1"/>
+          </p:cNvPicPr>
+          <p:nvPr/>
+        </p:nvPicPr>
+        <p:blipFill>
+          <a:blip r:embed="rId5"/>
+          <a:stretch>
+            <a:fillRect/>
+          </a:stretch>
+        </p:blipFill>
+        <p:spPr>
+          <a:xfrm>
+            <a:off x="6400800" y="4343399"/>
+            <a:ext cx="2355925" cy="457200"/>
+          </a:xfrm>
+          <a:prstGeom prst="rect">
+            <a:avLst/>
+          </a:prstGeom>
+        </p:spPr>
+      </p:pic>
+      <p:sp>
+        <p:nvSpPr>
+          <p:cNvPr id="22" name="TextBox 21"/>
+          <p:cNvSpPr txBox="1"/>
+          <p:nvPr/>
+        </p:nvSpPr>
+        <p:spPr>
+          <a:xfrm>
+            <a:off x="6355080" y="4892039"/>
+            <a:ext cx="4892040" cy="1280160"/>
+          </a:xfrm>
+          <a:prstGeom prst="rect">
+            <a:avLst/>
+          </a:prstGeom>
+          <a:noFill/>
+        </p:spPr>
+        <p:txBody>
+          <a:bodyPr wrap="square">
+            <a:spAutoFit/>
+          </a:bodyPr>
+          <a:lstStyle/>
+          <a:p>
+            <a:pPr>
+              <a:defRPr sz="919">
                 <a:solidFill>
                   <a:srgbClr val="0F172A"/>
                 </a:solidFill>
               </a:defRPr>
             </a:pPr>
             <a:r>
-              <a:t>Acoplamento físico-temporal: quantifica a ocorrência simultânea de chuva erosiva com solo exposto desprotegido (Karydas &amp; Panagos, 2018).</a:t>
+              <a:t>Fração temporal em que o solo permanece exposto ao impacto de chuva torrencial. Calibrado pelo sistema GEOS3 (Demattê et al., 2018; Safanelli et al., 2021).</a:t>
             </a:r>
           </a:p>
         </p:txBody>
@@ -4702,7 +4403,7 @@
               </a:defRPr>
             </a:pPr>
             <a:r>
-              <a:t>11. Cálculos Matemáticos: Otimização XGBoost e SHAP</a:t>
+              <a:t>11. Cálculos Matemáticos: Fatores RUSLE e Dinâmica G2</a:t>
             </a:r>
           </a:p>
         </p:txBody>
@@ -4795,8 +4496,8 @@
         </p:nvSpPr>
         <p:spPr>
           <a:xfrm>
-            <a:off x="731520" y="1371600"/>
-            <a:ext cx="5257800" cy="2240280"/>
+            <a:off x="731520" y="1280160"/>
+            <a:ext cx="5257800" cy="2423160"/>
           </a:xfrm>
           <a:prstGeom prst="roundRect">
             <a:avLst/>
@@ -4840,8 +4541,8 @@
         </p:nvSpPr>
         <p:spPr>
           <a:xfrm>
-            <a:off x="914400" y="1508760"/>
-            <a:ext cx="4892040" cy="1965960"/>
+            <a:off x="914400" y="1389888"/>
+            <a:ext cx="4892040" cy="365760"/>
           </a:xfrm>
           <a:prstGeom prst="rect">
             <a:avLst/>
@@ -4855,58 +4556,87 @@
           <a:lstStyle/>
           <a:p>
             <a:pPr>
-              <a:spcAft>
-                <a:spcPts val="400"/>
-              </a:spcAft>
-              <a:defRPr b="1" sz="1150">
+              <a:defRPr b="1" sz="1100">
                 <a:solidFill>
                   <a:srgbClr val="0F172A"/>
                 </a:solidFill>
               </a:defRPr>
             </a:pPr>
             <a:r>
-              <a:t>9. Função Objetivo do XGBoost (Chen &amp; Guestrin, 2016)</a:t>
-            </a:r>
-          </a:p>
-          <a:p>
-            <a:pPr>
-              <a:spcAft>
-                <a:spcPts val="600"/>
-              </a:spcAft>
-              <a:defRPr b="1" sz="1000">
-                <a:solidFill>
-                  <a:srgbClr val="BE123C"/>
-                </a:solidFill>
-              </a:defRPr>
-            </a:pPr>
-            <a:r>
-              <a:t>L^(t) ~ SUM [ gi·ft(xi) + 0.5·hi·ft^2(xi) ] + gamma·T + 0.5·lambda·SUM wj^2</a:t>
-            </a:r>
-          </a:p>
-          <a:p>
-            <a:pPr>
-              <a:defRPr sz="950">
+              <a:t>5. Fator C da RUSLE Regional Tropical (Decisão D01)</a:t>
+            </a:r>
+          </a:p>
+        </p:txBody>
+      </p:sp>
+      <p:pic>
+        <p:nvPicPr>
+          <p:cNvPr id="9" name="Picture 8" descr="formula_05_fator_c.png"/>
+          <p:cNvPicPr>
+            <a:picLocks noChangeAspect="1"/>
+          </p:cNvPicPr>
+          <p:nvPr/>
+        </p:nvPicPr>
+        <p:blipFill>
+          <a:blip r:embed="rId2"/>
+          <a:stretch>
+            <a:fillRect/>
+          </a:stretch>
+        </p:blipFill>
+        <p:spPr>
+          <a:xfrm>
+            <a:off x="960120" y="1783080"/>
+            <a:ext cx="2131888" cy="457200"/>
+          </a:xfrm>
+          <a:prstGeom prst="rect">
+            <a:avLst/>
+          </a:prstGeom>
+        </p:spPr>
+      </p:pic>
+      <p:sp>
+        <p:nvSpPr>
+          <p:cNvPr id="10" name="TextBox 9"/>
+          <p:cNvSpPr txBox="1"/>
+          <p:nvPr/>
+        </p:nvSpPr>
+        <p:spPr>
+          <a:xfrm>
+            <a:off x="914400" y="2331720"/>
+            <a:ext cx="4892040" cy="1280160"/>
+          </a:xfrm>
+          <a:prstGeom prst="rect">
+            <a:avLst/>
+          </a:prstGeom>
+          <a:noFill/>
+        </p:spPr>
+        <p:txBody>
+          <a:bodyPr wrap="square">
+            <a:spAutoFit/>
+          </a:bodyPr>
+          <a:lstStyle/>
+          <a:p>
+            <a:pPr>
+              <a:defRPr sz="919">
                 <a:solidFill>
                   <a:srgbClr val="0F172A"/>
                 </a:solidFill>
               </a:defRPr>
             </a:pPr>
             <a:r>
-              <a:t>Aproximação de Taylor de 2ª ordem da perda com gradientes gi e hessianas hi. Regularização L2 (lambda) e penalidade por número de folhas T (gamma) contra overfitting.</a:t>
-            </a:r>
-          </a:p>
-        </p:txBody>
-      </p:sp>
-      <p:sp>
-        <p:nvSpPr>
-          <p:cNvPr id="9" name="Rounded Rectangle 8"/>
+              <a:t>Modelo calibrado para bacias brasileiras por Durigon et al. (2014). Para solo nu (NDVI = 0.0), C = 0.50; para vegetação densa (NDVI = 0.80), C = 0.026. Evita subestimação.</a:t>
+            </a:r>
+          </a:p>
+        </p:txBody>
+      </p:sp>
+      <p:sp>
+        <p:nvSpPr>
+          <p:cNvPr id="11" name="Rounded Rectangle 10"/>
           <p:cNvSpPr/>
           <p:nvPr/>
         </p:nvSpPr>
         <p:spPr>
           <a:xfrm>
-            <a:off x="6172200" y="1371600"/>
-            <a:ext cx="5257800" cy="2240280"/>
+            <a:off x="6172200" y="1280160"/>
+            <a:ext cx="5257800" cy="2423160"/>
           </a:xfrm>
           <a:prstGeom prst="roundRect">
             <a:avLst/>
@@ -4944,14 +4674,14 @@
       </p:sp>
       <p:sp>
         <p:nvSpPr>
-          <p:cNvPr id="10" name="TextBox 9"/>
+          <p:cNvPr id="12" name="TextBox 11"/>
           <p:cNvSpPr txBox="1"/>
           <p:nvPr/>
         </p:nvSpPr>
         <p:spPr>
           <a:xfrm>
-            <a:off x="6355080" y="1508760"/>
-            <a:ext cx="4892040" cy="1965960"/>
+            <a:off x="6355080" y="1389888"/>
+            <a:ext cx="4892040" cy="365760"/>
           </a:xfrm>
           <a:prstGeom prst="rect">
             <a:avLst/>
@@ -4965,58 +4695,87 @@
           <a:lstStyle/>
           <a:p>
             <a:pPr>
-              <a:spcAft>
-                <a:spcPts val="400"/>
-              </a:spcAft>
-              <a:defRPr b="1" sz="1150">
+              <a:defRPr b="1" sz="1100">
                 <a:solidFill>
                   <a:srgbClr val="0F172A"/>
                 </a:solidFill>
               </a:defRPr>
             </a:pPr>
             <a:r>
-              <a:t>10. Critério de Ganho de Divisão de Árvore (Split Gain)</a:t>
-            </a:r>
-          </a:p>
-          <a:p>
-            <a:pPr>
-              <a:spcAft>
-                <a:spcPts val="600"/>
-              </a:spcAft>
-              <a:defRPr b="1" sz="1000">
-                <a:solidFill>
-                  <a:srgbClr val="BE123C"/>
-                </a:solidFill>
-              </a:defRPr>
-            </a:pPr>
-            <a:r>
-              <a:t>Gain = 0.5 * [ GL^2/(HL + lambda) + GR^2/(HR + lambda) - (G)^2/(H + lambda) ] - gamma</a:t>
-            </a:r>
-          </a:p>
-          <a:p>
-            <a:pPr>
-              <a:defRPr sz="950">
+              <a:t>6. Fator K Numérico (Tabela 5 Embrapa Solos / D14)</a:t>
+            </a:r>
+          </a:p>
+        </p:txBody>
+      </p:sp>
+      <p:pic>
+        <p:nvPicPr>
+          <p:cNvPr id="13" name="Picture 12" descr="formula_06_fator_k.png"/>
+          <p:cNvPicPr>
+            <a:picLocks noChangeAspect="1"/>
+          </p:cNvPicPr>
+          <p:nvPr/>
+        </p:nvPicPr>
+        <p:blipFill>
+          <a:blip r:embed="rId3"/>
+          <a:stretch>
+            <a:fillRect/>
+          </a:stretch>
+        </p:blipFill>
+        <p:spPr>
+          <a:xfrm>
+            <a:off x="6400800" y="1783080"/>
+            <a:ext cx="3827079" cy="457200"/>
+          </a:xfrm>
+          <a:prstGeom prst="rect">
+            <a:avLst/>
+          </a:prstGeom>
+        </p:spPr>
+      </p:pic>
+      <p:sp>
+        <p:nvSpPr>
+          <p:cNvPr id="14" name="TextBox 13"/>
+          <p:cNvSpPr txBox="1"/>
+          <p:nvPr/>
+        </p:nvSpPr>
+        <p:spPr>
+          <a:xfrm>
+            <a:off x="6355080" y="2331720"/>
+            <a:ext cx="4892040" cy="1280160"/>
+          </a:xfrm>
+          <a:prstGeom prst="rect">
+            <a:avLst/>
+          </a:prstGeom>
+          <a:noFill/>
+        </p:spPr>
+        <p:txBody>
+          <a:bodyPr wrap="square">
+            <a:spAutoFit/>
+          </a:bodyPr>
+          <a:lstStyle/>
+          <a:p>
+            <a:pPr>
+              <a:defRPr sz="919">
                 <a:solidFill>
                   <a:srgbClr val="0F172A"/>
                 </a:solidFill>
               </a:defRPr>
             </a:pPr>
             <a:r>
-              <a:t>Avalia se a divisão de um nó folha produz melhoria marginal superior ao custo de complexidade gamma da árvore.</a:t>
-            </a:r>
-          </a:p>
-        </p:txBody>
-      </p:sp>
-      <p:sp>
-        <p:nvSpPr>
-          <p:cNvPr id="11" name="Rounded Rectangle 10"/>
+              <a:t>Conversão oficial da carta pedológica para valores numéricos contínuos (Doc. 246/2024 / Mannigel et al., 2002). Estratificação K^: Nível 1 &lt;= 0.0285; Nível 2 &gt;= 0.0300 (D09).</a:t>
+            </a:r>
+          </a:p>
+        </p:txBody>
+      </p:sp>
+      <p:sp>
+        <p:nvSpPr>
+          <p:cNvPr id="15" name="Rounded Rectangle 14"/>
           <p:cNvSpPr/>
           <p:nvPr/>
         </p:nvSpPr>
         <p:spPr>
           <a:xfrm>
-            <a:off x="731520" y="3840480"/>
-            <a:ext cx="5257800" cy="2240280"/>
+            <a:off x="731520" y="3840479"/>
+            <a:ext cx="5257800" cy="2423160"/>
           </a:xfrm>
           <a:prstGeom prst="roundRect">
             <a:avLst/>
@@ -5054,14 +4813,14 @@
       </p:sp>
       <p:sp>
         <p:nvSpPr>
-          <p:cNvPr id="12" name="TextBox 11"/>
+          <p:cNvPr id="16" name="TextBox 15"/>
           <p:cNvSpPr txBox="1"/>
           <p:nvPr/>
         </p:nvSpPr>
         <p:spPr>
           <a:xfrm>
-            <a:off x="914400" y="3977640"/>
-            <a:ext cx="4892040" cy="1965960"/>
+            <a:off x="914400" y="3950207"/>
+            <a:ext cx="4892040" cy="365760"/>
           </a:xfrm>
           <a:prstGeom prst="rect">
             <a:avLst/>
@@ -5075,58 +4834,87 @@
           <a:lstStyle/>
           <a:p>
             <a:pPr>
-              <a:spcAft>
-                <a:spcPts val="400"/>
-              </a:spcAft>
-              <a:defRPr b="1" sz="1150">
+              <a:defRPr b="1" sz="1100">
                 <a:solidFill>
                   <a:srgbClr val="0F172A"/>
                 </a:solidFill>
               </a:defRPr>
             </a:pPr>
             <a:r>
-              <a:t>11. Concordância Inter-intérpretes (Kappa de Cohen)</a:t>
-            </a:r>
-          </a:p>
-          <a:p>
-            <a:pPr>
-              <a:spcAft>
-                <a:spcPts val="600"/>
-              </a:spcAft>
-              <a:defRPr b="1" sz="1000">
-                <a:solidFill>
-                  <a:srgbClr val="BE123C"/>
-                </a:solidFill>
-              </a:defRPr>
-            </a:pPr>
-            <a:r>
-              <a:t>kappa = (Po - Pe) / (1 - Pe)</a:t>
-            </a:r>
-          </a:p>
-          <a:p>
-            <a:pPr>
-              <a:defRPr sz="950">
+              <a:t>7. Equação de Perda de Solo (RUSLE)</a:t>
+            </a:r>
+          </a:p>
+        </p:txBody>
+      </p:sp>
+      <p:pic>
+        <p:nvPicPr>
+          <p:cNvPr id="17" name="Picture 16" descr="formula_07_rusle.png"/>
+          <p:cNvPicPr>
+            <a:picLocks noChangeAspect="1"/>
+          </p:cNvPicPr>
+          <p:nvPr/>
+        </p:nvPicPr>
+        <p:blipFill>
+          <a:blip r:embed="rId4"/>
+          <a:stretch>
+            <a:fillRect/>
+          </a:stretch>
+        </p:blipFill>
+        <p:spPr>
+          <a:xfrm>
+            <a:off x="960120" y="4343399"/>
+            <a:ext cx="2589486" cy="457200"/>
+          </a:xfrm>
+          <a:prstGeom prst="rect">
+            <a:avLst/>
+          </a:prstGeom>
+        </p:spPr>
+      </p:pic>
+      <p:sp>
+        <p:nvSpPr>
+          <p:cNvPr id="18" name="TextBox 17"/>
+          <p:cNvSpPr txBox="1"/>
+          <p:nvPr/>
+        </p:nvSpPr>
+        <p:spPr>
+          <a:xfrm>
+            <a:off x="914400" y="4892039"/>
+            <a:ext cx="4892040" cy="1280160"/>
+          </a:xfrm>
+          <a:prstGeom prst="rect">
+            <a:avLst/>
+          </a:prstGeom>
+          <a:noFill/>
+        </p:spPr>
+        <p:txBody>
+          <a:bodyPr wrap="square">
+            <a:spAutoFit/>
+          </a:bodyPr>
+          <a:lstStyle/>
+          <a:p>
+            <a:pPr>
+              <a:defRPr sz="919">
                 <a:solidFill>
                   <a:srgbClr val="0F172A"/>
                 </a:solidFill>
               </a:defRPr>
             </a:pPr>
             <a:r>
-              <a:t>Mede a concordância real Po descontada a concordância puramente casual Pe entre os dois fotointérpretes humanos independentes (Landis &amp; Koch, 1977).</a:t>
-            </a:r>
-          </a:p>
-        </p:txBody>
-      </p:sp>
-      <p:sp>
-        <p:nvSpPr>
-          <p:cNvPr id="13" name="Rounded Rectangle 12"/>
+              <a:t>Equação Universal de Perda de Solo Revisada (Renard et al., 1997). Invariante 1: só calculada se os 5 fatores e a memória de cálculo existirem simultaneamente.</a:t>
+            </a:r>
+          </a:p>
+        </p:txBody>
+      </p:sp>
+      <p:sp>
+        <p:nvSpPr>
+          <p:cNvPr id="19" name="Rounded Rectangle 18"/>
           <p:cNvSpPr/>
           <p:nvPr/>
         </p:nvSpPr>
         <p:spPr>
           <a:xfrm>
-            <a:off x="6172200" y="3840480"/>
-            <a:ext cx="5257800" cy="2240280"/>
+            <a:off x="6172200" y="3840479"/>
+            <a:ext cx="5257800" cy="2423160"/>
           </a:xfrm>
           <a:prstGeom prst="roundRect">
             <a:avLst/>
@@ -5164,14 +4952,14 @@
       </p:sp>
       <p:sp>
         <p:nvSpPr>
-          <p:cNvPr id="14" name="TextBox 13"/>
+          <p:cNvPr id="20" name="TextBox 19"/>
           <p:cNvSpPr txBox="1"/>
           <p:nvPr/>
         </p:nvSpPr>
         <p:spPr>
           <a:xfrm>
-            <a:off x="6355080" y="3977640"/>
-            <a:ext cx="4892040" cy="1965960"/>
+            <a:off x="6355080" y="3950207"/>
+            <a:ext cx="4892040" cy="365760"/>
           </a:xfrm>
           <a:prstGeom prst="rect">
             <a:avLst/>
@@ -5185,44 +4973,73 @@
           <a:lstStyle/>
           <a:p>
             <a:pPr>
-              <a:spcAft>
-                <a:spcPts val="400"/>
-              </a:spcAft>
-              <a:defRPr b="1" sz="1150">
+              <a:defRPr b="1" sz="1100">
                 <a:solidFill>
                   <a:srgbClr val="0F172A"/>
                 </a:solidFill>
               </a:defRPr>
             </a:pPr>
             <a:r>
-              <a:t>12. Valores SHAP de Explicabilidade Aditiva (Lundberg &amp; Lee, 2017)</a:t>
-            </a:r>
-          </a:p>
-          <a:p>
-            <a:pPr>
-              <a:spcAft>
-                <a:spcPts val="600"/>
-              </a:spcAft>
-              <a:defRPr b="1" sz="1000">
-                <a:solidFill>
-                  <a:srgbClr val="BE123C"/>
-                </a:solidFill>
-              </a:defRPr>
-            </a:pPr>
-            <a:r>
-              <a:t>phi_i(f, x) = SUM_{S} [ |S|!(|F|-|S|-1)! / |F|! ] * [ f(S U {i}) - f(S) ]</a:t>
-            </a:r>
-          </a:p>
-          <a:p>
-            <a:pPr>
-              <a:defRPr sz="950">
+              <a:t>8. Índice Dinâmico Chuva-Solo Nu (Modelo G2)</a:t>
+            </a:r>
+          </a:p>
+        </p:txBody>
+      </p:sp>
+      <p:pic>
+        <p:nvPicPr>
+          <p:cNvPr id="21" name="Picture 20" descr="formula_08_g2.png"/>
+          <p:cNvPicPr>
+            <a:picLocks noChangeAspect="1"/>
+          </p:cNvPicPr>
+          <p:nvPr/>
+        </p:nvPicPr>
+        <p:blipFill>
+          <a:blip r:embed="rId5"/>
+          <a:stretch>
+            <a:fillRect/>
+          </a:stretch>
+        </p:blipFill>
+        <p:spPr>
+          <a:xfrm>
+            <a:off x="6400800" y="4343399"/>
+            <a:ext cx="2648174" cy="457200"/>
+          </a:xfrm>
+          <a:prstGeom prst="rect">
+            <a:avLst/>
+          </a:prstGeom>
+        </p:spPr>
+      </p:pic>
+      <p:sp>
+        <p:nvSpPr>
+          <p:cNvPr id="22" name="TextBox 21"/>
+          <p:cNvSpPr txBox="1"/>
+          <p:nvPr/>
+        </p:nvSpPr>
+        <p:spPr>
+          <a:xfrm>
+            <a:off x="6355080" y="4892039"/>
+            <a:ext cx="4892040" cy="1280160"/>
+          </a:xfrm>
+          <a:prstGeom prst="rect">
+            <a:avLst/>
+          </a:prstGeom>
+          <a:noFill/>
+        </p:spPr>
+        <p:txBody>
+          <a:bodyPr wrap="square">
+            <a:spAutoFit/>
+          </a:bodyPr>
+          <a:lstStyle/>
+          <a:p>
+            <a:pPr>
+              <a:defRPr sz="919">
                 <a:solidFill>
                   <a:srgbClr val="0F172A"/>
                 </a:solidFill>
               </a:defRPr>
             </a:pPr>
             <a:r>
-              <a:t>Distribui o crédito marginal exato de cada preditor na probabilidade final de erosão, garantindo consistência teórica via teoria dos jogos.</a:t>
+              <a:t>Acoplamento físico-temporal: quantifica a ocorrência simultânea de chuva erosiva com solo exposto desprotegido (Karydas &amp; Panagos, 2018).</a:t>
             </a:r>
           </a:p>
         </p:txBody>
@@ -5363,7 +5180,7 @@
               </a:defRPr>
             </a:pPr>
             <a:r>
-              <a:t>12. Governança e Blindagem: 9 Regras e 7 Invariantes</a:t>
+              <a:t>12. Cálculos Matemáticos: Otimização XGBoost e SHAP</a:t>
             </a:r>
           </a:p>
         </p:txBody>
@@ -5457,7 +5274,7 @@
         <p:spPr>
           <a:xfrm>
             <a:off x="731520" y="1280160"/>
-            <a:ext cx="5257800" cy="4937760"/>
+            <a:ext cx="5257800" cy="2423160"/>
           </a:xfrm>
           <a:prstGeom prst="roundRect">
             <a:avLst/>
@@ -5467,7 +5284,7 @@
           </a:solidFill>
           <a:ln>
             <a:solidFill>
-              <a:srgbClr val="BE123C"/>
+              <a:srgbClr val="E2E8F0"/>
             </a:solidFill>
           </a:ln>
         </p:spPr>
@@ -5501,8 +5318,8 @@
         </p:nvSpPr>
         <p:spPr>
           <a:xfrm>
-            <a:off x="914400" y="1371600"/>
-            <a:ext cx="4892040" cy="4663440"/>
+            <a:off x="914400" y="1389888"/>
+            <a:ext cx="4892040" cy="365760"/>
           </a:xfrm>
           <a:prstGeom prst="rect">
             <a:avLst/>
@@ -5516,238 +5333,87 @@
           <a:lstStyle/>
           <a:p>
             <a:pPr>
-              <a:spcAft>
-                <a:spcPts val="600"/>
-              </a:spcAft>
-              <a:defRPr b="1" sz="1200">
-                <a:solidFill>
-                  <a:srgbClr val="BE123C"/>
-                </a:solidFill>
-              </a:defRPr>
-            </a:pPr>
-            <a:r>
-              <a:t>AS 9 REGRAS INVIOLÁVEIS DO SAREL</a:t>
-            </a:r>
-          </a:p>
-          <a:p>
-            <a:pPr>
-              <a:spcAft>
-                <a:spcPts val="200"/>
-              </a:spcAft>
-            </a:pPr>
-            <a:r>
-              <a:rPr b="1" sz="950">
-                <a:solidFill>
-                  <a:srgbClr val="BE123C"/>
-                </a:solidFill>
-              </a:rPr>
-              <a:t>R1 — Sem Valores Fabricados: </a:t>
-            </a:r>
-            <a:r>
-              <a:rPr sz="900">
+              <a:defRPr b="1" sz="1100">
                 <a:solidFill>
                   <a:srgbClr val="0F172A"/>
                 </a:solidFill>
-              </a:rPr>
-              <a:t>Ausência de dado permanece estritamente indisponivel.</a:t>
-            </a:r>
-          </a:p>
-          <a:p>
-            <a:pPr>
-              <a:spcAft>
-                <a:spcPts val="200"/>
-              </a:spcAft>
-            </a:pPr>
-            <a:r>
-              <a:rPr b="1" sz="950">
-                <a:solidFill>
-                  <a:srgbClr val="BE123C"/>
-                </a:solidFill>
-              </a:rPr>
-              <a:t>R2 — Sem Cortes Silenciosos: </a:t>
-            </a:r>
-            <a:r>
-              <a:rPr sz="900">
+              </a:defRPr>
+            </a:pPr>
+            <a:r>
+              <a:t>9. Função Objetivo do XGBoost (Chen &amp; Guestrin, 2016)</a:t>
+            </a:r>
+          </a:p>
+        </p:txBody>
+      </p:sp>
+      <p:pic>
+        <p:nvPicPr>
+          <p:cNvPr id="9" name="Picture 8" descr="formula_09_xgboost.png"/>
+          <p:cNvPicPr>
+            <a:picLocks noChangeAspect="1"/>
+          </p:cNvPicPr>
+          <p:nvPr/>
+        </p:nvPicPr>
+        <p:blipFill>
+          <a:blip r:embed="rId2"/>
+          <a:stretch>
+            <a:fillRect/>
+          </a:stretch>
+        </p:blipFill>
+        <p:spPr>
+          <a:xfrm>
+            <a:off x="960120" y="1783080"/>
+            <a:ext cx="3193822" cy="457200"/>
+          </a:xfrm>
+          <a:prstGeom prst="rect">
+            <a:avLst/>
+          </a:prstGeom>
+        </p:spPr>
+      </p:pic>
+      <p:sp>
+        <p:nvSpPr>
+          <p:cNvPr id="10" name="TextBox 9"/>
+          <p:cNvSpPr txBox="1"/>
+          <p:nvPr/>
+        </p:nvSpPr>
+        <p:spPr>
+          <a:xfrm>
+            <a:off x="914400" y="2331720"/>
+            <a:ext cx="4892040" cy="1280160"/>
+          </a:xfrm>
+          <a:prstGeom prst="rect">
+            <a:avLst/>
+          </a:prstGeom>
+          <a:noFill/>
+        </p:spPr>
+        <p:txBody>
+          <a:bodyPr wrap="square">
+            <a:spAutoFit/>
+          </a:bodyPr>
+          <a:lstStyle/>
+          <a:p>
+            <a:pPr>
+              <a:defRPr sz="919">
                 <a:solidFill>
                   <a:srgbClr val="0F172A"/>
                 </a:solidFill>
-              </a:rPr>
-              <a:t>Proibição de Math.max/min arbitrários; domínio estrito.</a:t>
-            </a:r>
-          </a:p>
-          <a:p>
-            <a:pPr>
-              <a:spcAft>
-                <a:spcPts val="200"/>
-              </a:spcAft>
-            </a:pPr>
-            <a:r>
-              <a:rPr b="1" sz="950">
-                <a:solidFill>
-                  <a:srgbClr val="BE123C"/>
-                </a:solidFill>
-              </a:rPr>
-              <a:t>R3 — Rastreabilidade Total: </a:t>
-            </a:r>
-            <a:r>
-              <a:rPr sz="900">
-                <a:solidFill>
-                  <a:srgbClr val="0F172A"/>
-                </a:solidFill>
-              </a:rPr>
-              <a:t>Encapsulamento em Proveniencia&lt;T&gt;.</a:t>
-            </a:r>
-          </a:p>
-          <a:p>
-            <a:pPr>
-              <a:spcAft>
-                <a:spcPts val="200"/>
-              </a:spcAft>
-            </a:pPr>
-            <a:r>
-              <a:rPr b="1" sz="950">
-                <a:solidFill>
-                  <a:srgbClr val="BE123C"/>
-                </a:solidFill>
-              </a:rPr>
-              <a:t>R4 — Nada Calculado Vira Rótulo: </a:t>
-            </a:r>
-            <a:r>
-              <a:rPr sz="900">
-                <a:solidFill>
-                  <a:srgbClr val="0F172A"/>
-                </a:solidFill>
-              </a:rPr>
-              <a:t>Modelos ou IA jamais viram verdade terrestre.</a:t>
-            </a:r>
-          </a:p>
-          <a:p>
-            <a:pPr>
-              <a:spcAft>
-                <a:spcPts val="200"/>
-              </a:spcAft>
-            </a:pPr>
-            <a:r>
-              <a:rPr b="1" sz="950">
-                <a:solidFill>
-                  <a:srgbClr val="BE123C"/>
-                </a:solidFill>
-              </a:rPr>
-              <a:t>R5 — Guarda Antissintética: </a:t>
-            </a:r>
-            <a:r>
-              <a:rPr sz="900">
-                <a:solidFill>
-                  <a:srgbClr val="0F172A"/>
-                </a:solidFill>
-              </a:rPr>
-              <a:t>Proibição universal de pontos com origemSintetica: true.</a:t>
-            </a:r>
-          </a:p>
-          <a:p>
-            <a:pPr>
-              <a:spcAft>
-                <a:spcPts val="200"/>
-              </a:spcAft>
-            </a:pPr>
-            <a:r>
-              <a:rPr b="1" sz="950">
-                <a:solidFill>
-                  <a:srgbClr val="BE123C"/>
-                </a:solidFill>
-              </a:rPr>
-              <a:t>R6 — Segregação Cega: </a:t>
-            </a:r>
-            <a:r>
-              <a:rPr sz="900">
-                <a:solidFill>
-                  <a:srgbClr val="0F172A"/>
-                </a:solidFill>
-              </a:rPr>
-              <a:t>Coordenadas não entram na matriz de treino tabular.</a:t>
-            </a:r>
-          </a:p>
-          <a:p>
-            <a:pPr>
-              <a:spcAft>
-                <a:spcPts val="200"/>
-              </a:spcAft>
-            </a:pPr>
-            <a:r>
-              <a:rPr b="1" sz="950">
-                <a:solidFill>
-                  <a:srgbClr val="BE123C"/>
-                </a:solidFill>
-              </a:rPr>
-              <a:t>R7 — Preservação de Máscaras: </a:t>
-            </a:r>
-            <a:r>
-              <a:rPr sz="900">
-                <a:solidFill>
-                  <a:srgbClr val="0F172A"/>
-                </a:solidFill>
-              </a:rPr>
-              <a:t>Nuvens e sombras mantidas como lacunas reais.</a:t>
-            </a:r>
-          </a:p>
-          <a:p>
-            <a:pPr>
-              <a:spcAft>
-                <a:spcPts val="200"/>
-              </a:spcAft>
-            </a:pPr>
-            <a:r>
-              <a:rPr b="1" sz="950">
-                <a:solidFill>
-                  <a:srgbClr val="BE123C"/>
-                </a:solidFill>
-              </a:rPr>
-              <a:t>R8 — Evidência de Verificação: </a:t>
-            </a:r>
-            <a:r>
-              <a:rPr sz="900">
-                <a:solidFill>
-                  <a:srgbClr val="0F172A"/>
-                </a:solidFill>
-              </a:rPr>
-              <a:t>Asserções exigem arquivos físicos de prova.</a:t>
-            </a:r>
-          </a:p>
-          <a:p>
-            <a:pPr>
-              <a:spcAft>
-                <a:spcPts val="200"/>
-              </a:spcAft>
-            </a:pPr>
-            <a:r>
-              <a:rPr b="1" sz="950">
-                <a:solidFill>
-                  <a:srgbClr val="BE123C"/>
-                </a:solidFill>
-              </a:rPr>
-              <a:t>R9 — Preservação Histórica: </a:t>
-            </a:r>
-            <a:r>
-              <a:rPr sz="900">
-                <a:solidFill>
-                  <a:srgbClr val="0F172A"/>
-                </a:solidFill>
-              </a:rPr>
-              <a:t>Rastreabilidade e integridade via branch sarel/v2.</a:t>
-            </a:r>
-          </a:p>
-        </p:txBody>
-      </p:sp>
-      <p:sp>
-        <p:nvSpPr>
-          <p:cNvPr id="9" name="Rounded Rectangle 8"/>
+              </a:defRPr>
+            </a:pPr>
+            <a:r>
+              <a:t>Aproximação de Taylor de 2ª ordem da perda com gradientes gi e hessianas hi. Regularização L2 (lambda) e penalidade por número de folhas T (gamma) contra overfitting.</a:t>
+            </a:r>
+          </a:p>
+        </p:txBody>
+      </p:sp>
+      <p:sp>
+        <p:nvSpPr>
+          <p:cNvPr id="11" name="Rounded Rectangle 10"/>
           <p:cNvSpPr/>
           <p:nvPr/>
         </p:nvSpPr>
         <p:spPr>
           <a:xfrm>
-            <a:off x="6217920" y="1280160"/>
-            <a:ext cx="5257800" cy="4937760"/>
+            <a:off x="6172200" y="1280160"/>
+            <a:ext cx="5257800" cy="2423160"/>
           </a:xfrm>
           <a:prstGeom prst="roundRect">
             <a:avLst/>
@@ -5757,7 +5423,7 @@
           </a:solidFill>
           <a:ln>
             <a:solidFill>
-              <a:srgbClr val="065F46"/>
+              <a:srgbClr val="E2E8F0"/>
             </a:solidFill>
           </a:ln>
         </p:spPr>
@@ -5785,14 +5451,14 @@
       </p:sp>
       <p:sp>
         <p:nvSpPr>
-          <p:cNvPr id="10" name="TextBox 9"/>
+          <p:cNvPr id="12" name="TextBox 11"/>
           <p:cNvSpPr txBox="1"/>
           <p:nvPr/>
         </p:nvSpPr>
         <p:spPr>
           <a:xfrm>
-            <a:off x="6400800" y="1371600"/>
-            <a:ext cx="4892040" cy="4663440"/>
+            <a:off x="6355080" y="1389888"/>
+            <a:ext cx="4892040" cy="365760"/>
           </a:xfrm>
           <a:prstGeom prst="rect">
             <a:avLst/>
@@ -5806,178 +5472,351 @@
           <a:lstStyle/>
           <a:p>
             <a:pPr>
-              <a:spcAft>
-                <a:spcPts val="600"/>
-              </a:spcAft>
-              <a:defRPr b="1" sz="1200">
-                <a:solidFill>
-                  <a:srgbClr val="065F46"/>
-                </a:solidFill>
-              </a:defRPr>
-            </a:pPr>
-            <a:r>
-              <a:t>OS 7 INVARIANTES DE INTEGRIDADE COMPUTACIONAL</a:t>
-            </a:r>
-          </a:p>
-          <a:p>
-            <a:pPr>
-              <a:spcAft>
-                <a:spcPts val="400"/>
-              </a:spcAft>
-            </a:pPr>
-            <a:r>
-              <a:rPr b="1" sz="950">
-                <a:solidFill>
-                  <a:srgbClr val="065F46"/>
-                </a:solidFill>
-              </a:rPr>
-              <a:t>Invariante 1: </a:t>
-            </a:r>
-            <a:r>
-              <a:rPr sz="900">
+              <a:defRPr b="1" sz="1100">
                 <a:solidFill>
                   <a:srgbClr val="0F172A"/>
                 </a:solidFill>
-              </a:rPr>
-              <a:t>RUSLE completa: perdaSolo &lt;=&gt; 5 fatores presentes &lt;=&gt; memória cálculo.</a:t>
-            </a:r>
-          </a:p>
-          <a:p>
-            <a:pPr>
-              <a:spcAft>
-                <a:spcPts val="400"/>
-              </a:spcAft>
-            </a:pPr>
-            <a:r>
-              <a:rPr b="1" sz="950">
-                <a:solidFill>
-                  <a:srgbClr val="065F46"/>
-                </a:solidFill>
-              </a:rPr>
-              <a:t>Invariante 2: </a:t>
-            </a:r>
-            <a:r>
-              <a:rPr sz="900">
+              </a:defRPr>
+            </a:pPr>
+            <a:r>
+              <a:t>10. Critério de Ganho de Divisão de Árvore (Split Gain)</a:t>
+            </a:r>
+          </a:p>
+        </p:txBody>
+      </p:sp>
+      <p:pic>
+        <p:nvPicPr>
+          <p:cNvPr id="13" name="Picture 12" descr="formula_10_split_gain.png"/>
+          <p:cNvPicPr>
+            <a:picLocks noChangeAspect="1"/>
+          </p:cNvPicPr>
+          <p:nvPr/>
+        </p:nvPicPr>
+        <p:blipFill>
+          <a:blip r:embed="rId3"/>
+          <a:stretch>
+            <a:fillRect/>
+          </a:stretch>
+        </p:blipFill>
+        <p:spPr>
+          <a:xfrm>
+            <a:off x="6400800" y="1783080"/>
+            <a:ext cx="3040873" cy="457200"/>
+          </a:xfrm>
+          <a:prstGeom prst="rect">
+            <a:avLst/>
+          </a:prstGeom>
+        </p:spPr>
+      </p:pic>
+      <p:sp>
+        <p:nvSpPr>
+          <p:cNvPr id="14" name="TextBox 13"/>
+          <p:cNvSpPr txBox="1"/>
+          <p:nvPr/>
+        </p:nvSpPr>
+        <p:spPr>
+          <a:xfrm>
+            <a:off x="6355080" y="2331720"/>
+            <a:ext cx="4892040" cy="1280160"/>
+          </a:xfrm>
+          <a:prstGeom prst="rect">
+            <a:avLst/>
+          </a:prstGeom>
+          <a:noFill/>
+        </p:spPr>
+        <p:txBody>
+          <a:bodyPr wrap="square">
+            <a:spAutoFit/>
+          </a:bodyPr>
+          <a:lstStyle/>
+          <a:p>
+            <a:pPr>
+              <a:defRPr sz="919">
                 <a:solidFill>
                   <a:srgbClr val="0F172A"/>
                 </a:solidFill>
-              </a:rPr>
-              <a:t>Lista de permissão estrita: bloqueia vazamento de Phi_diag ou coordenadas.</a:t>
-            </a:r>
-          </a:p>
-          <a:p>
-            <a:pPr>
-              <a:spcAft>
-                <a:spcPts val="400"/>
-              </a:spcAft>
-            </a:pPr>
-            <a:r>
-              <a:rPr b="1" sz="950">
-                <a:solidFill>
-                  <a:srgbClr val="065F46"/>
-                </a:solidFill>
-              </a:rPr>
-              <a:t>Invariante 3: </a:t>
-            </a:r>
-            <a:r>
-              <a:rPr sz="900">
+              </a:defRPr>
+            </a:pPr>
+            <a:r>
+              <a:t>Avalia se a divisão de um nó folha produz melhoria marginal superior ao custo de complexidade gamma da árvore.</a:t>
+            </a:r>
+          </a:p>
+        </p:txBody>
+      </p:sp>
+      <p:sp>
+        <p:nvSpPr>
+          <p:cNvPr id="15" name="Rounded Rectangle 14"/>
+          <p:cNvSpPr/>
+          <p:nvPr/>
+        </p:nvSpPr>
+        <p:spPr>
+          <a:xfrm>
+            <a:off x="731520" y="3840479"/>
+            <a:ext cx="5257800" cy="2423160"/>
+          </a:xfrm>
+          <a:prstGeom prst="roundRect">
+            <a:avLst/>
+          </a:prstGeom>
+          <a:solidFill>
+            <a:srgbClr val="FFFFFF"/>
+          </a:solidFill>
+          <a:ln>
+            <a:solidFill>
+              <a:srgbClr val="E2E8F0"/>
+            </a:solidFill>
+          </a:ln>
+        </p:spPr>
+        <p:style>
+          <a:lnRef idx="1">
+            <a:schemeClr val="accent1"/>
+          </a:lnRef>
+          <a:fillRef idx="3">
+            <a:schemeClr val="accent1"/>
+          </a:fillRef>
+          <a:effectRef idx="2">
+            <a:schemeClr val="accent1"/>
+          </a:effectRef>
+          <a:fontRef idx="minor">
+            <a:schemeClr val="lt1"/>
+          </a:fontRef>
+        </p:style>
+        <p:txBody>
+          <a:bodyPr rtlCol="0" anchor="ctr"/>
+          <a:lstStyle/>
+          <a:p>
+            <a:pPr algn="ctr"/>
+          </a:p>
+        </p:txBody>
+      </p:sp>
+      <p:sp>
+        <p:nvSpPr>
+          <p:cNvPr id="16" name="TextBox 15"/>
+          <p:cNvSpPr txBox="1"/>
+          <p:nvPr/>
+        </p:nvSpPr>
+        <p:spPr>
+          <a:xfrm>
+            <a:off x="914400" y="3950207"/>
+            <a:ext cx="4892040" cy="365760"/>
+          </a:xfrm>
+          <a:prstGeom prst="rect">
+            <a:avLst/>
+          </a:prstGeom>
+          <a:noFill/>
+        </p:spPr>
+        <p:txBody>
+          <a:bodyPr wrap="square">
+            <a:spAutoFit/>
+          </a:bodyPr>
+          <a:lstStyle/>
+          <a:p>
+            <a:pPr>
+              <a:defRPr b="1" sz="1100">
                 <a:solidFill>
                   <a:srgbClr val="0F172A"/>
                 </a:solidFill>
-              </a:rPr>
-              <a:t>Campos estimados derivados rigorosamente de estados não medidos.</a:t>
-            </a:r>
-          </a:p>
-          <a:p>
-            <a:pPr>
-              <a:spcAft>
-                <a:spcPts val="400"/>
-              </a:spcAft>
-            </a:pPr>
-            <a:r>
-              <a:rPr b="1" sz="950">
-                <a:solidFill>
-                  <a:srgbClr val="065F46"/>
-                </a:solidFill>
-              </a:rPr>
-              <a:t>Invariante 4: </a:t>
-            </a:r>
-            <a:r>
-              <a:rPr sz="900">
+              </a:defRPr>
+            </a:pPr>
+            <a:r>
+              <a:t>11. Concordância Inter-intérpretes (Kappa de Cohen)</a:t>
+            </a:r>
+          </a:p>
+        </p:txBody>
+      </p:sp>
+      <p:pic>
+        <p:nvPicPr>
+          <p:cNvPr id="17" name="Picture 16" descr="formula_11_kappa.png"/>
+          <p:cNvPicPr>
+            <a:picLocks noChangeAspect="1"/>
+          </p:cNvPicPr>
+          <p:nvPr/>
+        </p:nvPicPr>
+        <p:blipFill>
+          <a:blip r:embed="rId4"/>
+          <a:stretch>
+            <a:fillRect/>
+          </a:stretch>
+        </p:blipFill>
+        <p:spPr>
+          <a:xfrm>
+            <a:off x="960120" y="4343399"/>
+            <a:ext cx="1729081" cy="457200"/>
+          </a:xfrm>
+          <a:prstGeom prst="rect">
+            <a:avLst/>
+          </a:prstGeom>
+        </p:spPr>
+      </p:pic>
+      <p:sp>
+        <p:nvSpPr>
+          <p:cNvPr id="18" name="TextBox 17"/>
+          <p:cNvSpPr txBox="1"/>
+          <p:nvPr/>
+        </p:nvSpPr>
+        <p:spPr>
+          <a:xfrm>
+            <a:off x="914400" y="4892039"/>
+            <a:ext cx="4892040" cy="1280160"/>
+          </a:xfrm>
+          <a:prstGeom prst="rect">
+            <a:avLst/>
+          </a:prstGeom>
+          <a:noFill/>
+        </p:spPr>
+        <p:txBody>
+          <a:bodyPr wrap="square">
+            <a:spAutoFit/>
+          </a:bodyPr>
+          <a:lstStyle/>
+          <a:p>
+            <a:pPr>
+              <a:defRPr sz="919">
                 <a:solidFill>
                   <a:srgbClr val="0F172A"/>
                 </a:solidFill>
-              </a:rPr>
-              <a:t>Rastreabilidade orbital: exigência de PRODUCT_ID, motor e timestamp.</a:t>
-            </a:r>
-          </a:p>
-          <a:p>
-            <a:pPr>
-              <a:spcAft>
-                <a:spcPts val="400"/>
-              </a:spcAft>
-            </a:pPr>
-            <a:r>
-              <a:rPr b="1" sz="950">
-                <a:solidFill>
-                  <a:srgbClr val="065F46"/>
-                </a:solidFill>
-              </a:rPr>
-              <a:t>Invariante 5: </a:t>
-            </a:r>
-            <a:r>
-              <a:rPr sz="900">
+              </a:defRPr>
+            </a:pPr>
+            <a:r>
+              <a:t>Mede a concordância real Po descontada a concordância puramente casual Pe entre os dois fotointérpretes humanos independentes (Landis &amp; Koch, 1977).</a:t>
+            </a:r>
+          </a:p>
+        </p:txBody>
+      </p:sp>
+      <p:sp>
+        <p:nvSpPr>
+          <p:cNvPr id="19" name="Rounded Rectangle 18"/>
+          <p:cNvSpPr/>
+          <p:nvPr/>
+        </p:nvSpPr>
+        <p:spPr>
+          <a:xfrm>
+            <a:off x="6172200" y="3840479"/>
+            <a:ext cx="5257800" cy="2423160"/>
+          </a:xfrm>
+          <a:prstGeom prst="roundRect">
+            <a:avLst/>
+          </a:prstGeom>
+          <a:solidFill>
+            <a:srgbClr val="FFFFFF"/>
+          </a:solidFill>
+          <a:ln>
+            <a:solidFill>
+              <a:srgbClr val="E2E8F0"/>
+            </a:solidFill>
+          </a:ln>
+        </p:spPr>
+        <p:style>
+          <a:lnRef idx="1">
+            <a:schemeClr val="accent1"/>
+          </a:lnRef>
+          <a:fillRef idx="3">
+            <a:schemeClr val="accent1"/>
+          </a:fillRef>
+          <a:effectRef idx="2">
+            <a:schemeClr val="accent1"/>
+          </a:effectRef>
+          <a:fontRef idx="minor">
+            <a:schemeClr val="lt1"/>
+          </a:fontRef>
+        </p:style>
+        <p:txBody>
+          <a:bodyPr rtlCol="0" anchor="ctr"/>
+          <a:lstStyle/>
+          <a:p>
+            <a:pPr algn="ctr"/>
+          </a:p>
+        </p:txBody>
+      </p:sp>
+      <p:sp>
+        <p:nvSpPr>
+          <p:cNvPr id="20" name="TextBox 19"/>
+          <p:cNvSpPr txBox="1"/>
+          <p:nvPr/>
+        </p:nvSpPr>
+        <p:spPr>
+          <a:xfrm>
+            <a:off x="6355080" y="3950207"/>
+            <a:ext cx="4892040" cy="365760"/>
+          </a:xfrm>
+          <a:prstGeom prst="rect">
+            <a:avLst/>
+          </a:prstGeom>
+          <a:noFill/>
+        </p:spPr>
+        <p:txBody>
+          <a:bodyPr wrap="square">
+            <a:spAutoFit/>
+          </a:bodyPr>
+          <a:lstStyle/>
+          <a:p>
+            <a:pPr>
+              <a:defRPr b="1" sz="1100">
                 <a:solidFill>
                   <a:srgbClr val="0F172A"/>
                 </a:solidFill>
-              </a:rPr>
-              <a:t>Afirmação negativa fundiária: exige histórico sem match geográfico.</a:t>
-            </a:r>
-          </a:p>
-          <a:p>
-            <a:pPr>
-              <a:spcAft>
-                <a:spcPts val="400"/>
-              </a:spcAft>
-            </a:pPr>
-            <a:r>
-              <a:rPr b="1" sz="950">
-                <a:solidFill>
-                  <a:srgbClr val="065F46"/>
-                </a:solidFill>
-              </a:rPr>
-              <a:t>Invariante 6: </a:t>
-            </a:r>
-            <a:r>
-              <a:rPr sz="900">
+              </a:defRPr>
+            </a:pPr>
+            <a:r>
+              <a:t>12. Valores SHAP de Explicabilidade Aditiva (Lundberg &amp; Lee, 2017)</a:t>
+            </a:r>
+          </a:p>
+        </p:txBody>
+      </p:sp>
+      <p:pic>
+        <p:nvPicPr>
+          <p:cNvPr id="21" name="Picture 20" descr="formula_12_shap.png"/>
+          <p:cNvPicPr>
+            <a:picLocks noChangeAspect="1"/>
+          </p:cNvPicPr>
+          <p:nvPr/>
+        </p:nvPicPr>
+        <p:blipFill>
+          <a:blip r:embed="rId5"/>
+          <a:stretch>
+            <a:fillRect/>
+          </a:stretch>
+        </p:blipFill>
+        <p:spPr>
+          <a:xfrm>
+            <a:off x="6400800" y="4343399"/>
+            <a:ext cx="3308944" cy="457200"/>
+          </a:xfrm>
+          <a:prstGeom prst="rect">
+            <a:avLst/>
+          </a:prstGeom>
+        </p:spPr>
+      </p:pic>
+      <p:sp>
+        <p:nvSpPr>
+          <p:cNvPr id="22" name="TextBox 21"/>
+          <p:cNvSpPr txBox="1"/>
+          <p:nvPr/>
+        </p:nvSpPr>
+        <p:spPr>
+          <a:xfrm>
+            <a:off x="6355080" y="4892039"/>
+            <a:ext cx="4892040" cy="1280160"/>
+          </a:xfrm>
+          <a:prstGeom prst="rect">
+            <a:avLst/>
+          </a:prstGeom>
+          <a:noFill/>
+        </p:spPr>
+        <p:txBody>
+          <a:bodyPr wrap="square">
+            <a:spAutoFit/>
+          </a:bodyPr>
+          <a:lstStyle/>
+          <a:p>
+            <a:pPr>
+              <a:defRPr sz="919">
                 <a:solidFill>
                   <a:srgbClr val="0F172A"/>
                 </a:solidFill>
-              </a:rPr>
-              <a:t>Proibição de literais espúrios ('Custom', 'Bacia Local', etc.).</a:t>
-            </a:r>
-          </a:p>
-          <a:p>
-            <a:pPr>
-              <a:spcAft>
-                <a:spcPts val="400"/>
-              </a:spcAft>
-            </a:pPr>
-            <a:r>
-              <a:rPr b="1" sz="950">
-                <a:solidFill>
-                  <a:srgbClr val="065F46"/>
-                </a:solidFill>
-              </a:rPr>
-              <a:t>Invariante 7: </a:t>
-            </a:r>
-            <a:r>
-              <a:rPr sz="900">
-                <a:solidFill>
-                  <a:srgbClr val="0F172A"/>
-                </a:solidFill>
-              </a:rPr>
-              <a:t>Detector de constante disfarçada: recusa colunas numéricas estáticas.</a:t>
+              </a:defRPr>
+            </a:pPr>
+            <a:r>
+              <a:t>Distribui o crédito marginal exato de cada preditor na probabilidade final de erosão, garantindo consistência teórica via teoria dos jogos.</a:t>
             </a:r>
           </a:p>
         </p:txBody>
@@ -6118,7 +5957,7 @@
               </a:defRPr>
             </a:pPr>
             <a:r>
-              <a:t>13. Segregação Temporal: Modelo D vs. Modelo P</a:t>
+              <a:t>13. Governança e Blindagem: 9 Regras e 7 Invariantes</a:t>
             </a:r>
           </a:p>
         </p:txBody>
@@ -6211,8 +6050,8 @@
         </p:nvSpPr>
         <p:spPr>
           <a:xfrm>
-            <a:off x="731520" y="1371600"/>
-            <a:ext cx="5257800" cy="4846320"/>
+            <a:off x="731520" y="1280160"/>
+            <a:ext cx="5257800" cy="4937760"/>
           </a:xfrm>
           <a:prstGeom prst="roundRect">
             <a:avLst/>
@@ -6222,7 +6061,7 @@
           </a:solidFill>
           <a:ln>
             <a:solidFill>
-              <a:srgbClr val="0EA5E9"/>
+              <a:srgbClr val="BE123C"/>
             </a:solidFill>
           </a:ln>
         </p:spPr>
@@ -6256,8 +6095,8 @@
         </p:nvSpPr>
         <p:spPr>
           <a:xfrm>
-            <a:off x="914400" y="1463040"/>
-            <a:ext cx="4892040" cy="4572000"/>
+            <a:off x="914400" y="1371600"/>
+            <a:ext cx="4892040" cy="4663440"/>
           </a:xfrm>
           <a:prstGeom prst="rect">
             <a:avLst/>
@@ -6272,108 +6111,223 @@
           <a:p>
             <a:pPr>
               <a:spcAft>
-                <a:spcPts val="800"/>
+                <a:spcPts val="600"/>
               </a:spcAft>
-              <a:defRPr b="1" sz="1300">
-                <a:solidFill>
-                  <a:srgbClr val="0369A1"/>
-                </a:solidFill>
-              </a:defRPr>
-            </a:pPr>
-            <a:r>
-              <a:t>MODELO D — DETECÇÃO CONTEMPORÂNEA</a:t>
+              <a:defRPr b="1" sz="1200">
+                <a:solidFill>
+                  <a:srgbClr val="BE123C"/>
+                </a:solidFill>
+              </a:defRPr>
+            </a:pPr>
+            <a:r>
+              <a:t>AS 9 REGRAS INVIOLÁVEIS DO SAREL</a:t>
             </a:r>
           </a:p>
           <a:p>
             <a:pPr>
               <a:spcAft>
-                <a:spcPts val="800"/>
+                <a:spcPts val="200"/>
               </a:spcAft>
             </a:pPr>
             <a:r>
-              <a:rPr b="1" sz="1000">
-                <a:solidFill>
-                  <a:srgbClr val="0369A1"/>
+              <a:rPr b="1" sz="950">
+                <a:solidFill>
+                  <a:srgbClr val="BE123C"/>
                 </a:solidFill>
               </a:rPr>
-              <a:t>• Finalidade Operacional: </a:t>
-            </a:r>
-            <a:r>
-              <a:rPr sz="950">
+              <a:t>R1 — Sem Valores Fabricados: </a:t>
+            </a:r>
+            <a:r>
+              <a:rPr sz="900">
                 <a:solidFill>
                   <a:srgbClr val="0F172A"/>
                 </a:solidFill>
               </a:rPr>
-              <a:t>Mapear feições de erosão laminar que JÁ se manifestaram visualmente no terreno (diagnóstico pericial contemporâneo).</a:t>
+              <a:t>Ausência de dado permanece estritamente indisponivel.</a:t>
             </a:r>
           </a:p>
           <a:p>
             <a:pPr>
               <a:spcAft>
-                <a:spcPts val="800"/>
+                <a:spcPts val="200"/>
               </a:spcAft>
             </a:pPr>
             <a:r>
-              <a:rPr b="1" sz="1000">
-                <a:solidFill>
-                  <a:srgbClr val="0369A1"/>
+              <a:rPr b="1" sz="950">
+                <a:solidFill>
+                  <a:srgbClr val="BE123C"/>
                 </a:solidFill>
               </a:rPr>
-              <a:t>• Extensão da Janela Temporal: </a:t>
-            </a:r>
-            <a:r>
-              <a:rPr sz="950">
+              <a:t>R2 — Sem Cortes Silenciosos: </a:t>
+            </a:r>
+            <a:r>
+              <a:rPr sz="900">
                 <a:solidFill>
                   <a:srgbClr val="0F172A"/>
                 </a:solidFill>
               </a:rPr>
-              <a:t>Série temporal orbitando continuamente até a data exata do evento ou inspeção pericial (t0).</a:t>
+              <a:t>Proibição de Math.max/min arbitrários; domínio estrito.</a:t>
             </a:r>
           </a:p>
           <a:p>
             <a:pPr>
               <a:spcAft>
-                <a:spcPts val="800"/>
+                <a:spcPts val="200"/>
               </a:spcAft>
             </a:pPr>
             <a:r>
-              <a:rPr b="1" sz="1000">
-                <a:solidFill>
-                  <a:srgbClr val="0369A1"/>
+              <a:rPr b="1" sz="950">
+                <a:solidFill>
+                  <a:srgbClr val="BE123C"/>
                 </a:solidFill>
               </a:rPr>
-              <a:t>• Assinatura Biofísica: </a:t>
-            </a:r>
-            <a:r>
-              <a:rPr sz="950">
+              <a:t>R3 — Rastreabilidade Total: </a:t>
+            </a:r>
+            <a:r>
+              <a:rPr sz="900">
                 <a:solidFill>
                   <a:srgbClr val="0F172A"/>
                 </a:solidFill>
               </a:rPr>
-              <a:t>Detecta horizonte B exposto, BSI &gt; 0.10, redução drástica de biomassa e empobrecimento em carbono orgânico.</a:t>
+              <a:t>Encapsulamento em Proveniencia&lt;T&gt;.</a:t>
             </a:r>
           </a:p>
           <a:p>
             <a:pPr>
               <a:spcAft>
-                <a:spcPts val="800"/>
+                <a:spcPts val="200"/>
               </a:spcAft>
             </a:pPr>
             <a:r>
-              <a:rPr b="1" sz="1000">
-                <a:solidFill>
-                  <a:srgbClr val="0369A1"/>
+              <a:rPr b="1" sz="950">
+                <a:solidFill>
+                  <a:srgbClr val="BE123C"/>
                 </a:solidFill>
               </a:rPr>
-              <a:t>• Aplicação Prática: </a:t>
-            </a:r>
-            <a:r>
-              <a:rPr sz="950">
+              <a:t>R4 — Nada Calculado Vira Rótulo: </a:t>
+            </a:r>
+            <a:r>
+              <a:rPr sz="900">
                 <a:solidFill>
                   <a:srgbClr val="0F172A"/>
                 </a:solidFill>
               </a:rPr>
-              <a:t>Perícia judicial ambiental, fiscalização agropecuária, apuração de responsabilidade por degradação e autuações.</a:t>
+              <a:t>Modelos ou IA jamais viram verdade terrestre.</a:t>
+            </a:r>
+          </a:p>
+          <a:p>
+            <a:pPr>
+              <a:spcAft>
+                <a:spcPts val="200"/>
+              </a:spcAft>
+            </a:pPr>
+            <a:r>
+              <a:rPr b="1" sz="950">
+                <a:solidFill>
+                  <a:srgbClr val="BE123C"/>
+                </a:solidFill>
+              </a:rPr>
+              <a:t>R5 — Guarda Antissintética: </a:t>
+            </a:r>
+            <a:r>
+              <a:rPr sz="900">
+                <a:solidFill>
+                  <a:srgbClr val="0F172A"/>
+                </a:solidFill>
+              </a:rPr>
+              <a:t>Proibição universal de pontos com origemSintetica: true.</a:t>
+            </a:r>
+          </a:p>
+          <a:p>
+            <a:pPr>
+              <a:spcAft>
+                <a:spcPts val="200"/>
+              </a:spcAft>
+            </a:pPr>
+            <a:r>
+              <a:rPr b="1" sz="950">
+                <a:solidFill>
+                  <a:srgbClr val="BE123C"/>
+                </a:solidFill>
+              </a:rPr>
+              <a:t>R6 — Segregação Cega: </a:t>
+            </a:r>
+            <a:r>
+              <a:rPr sz="900">
+                <a:solidFill>
+                  <a:srgbClr val="0F172A"/>
+                </a:solidFill>
+              </a:rPr>
+              <a:t>Coordenadas não entram na matriz de treino tabular.</a:t>
+            </a:r>
+          </a:p>
+          <a:p>
+            <a:pPr>
+              <a:spcAft>
+                <a:spcPts val="200"/>
+              </a:spcAft>
+            </a:pPr>
+            <a:r>
+              <a:rPr b="1" sz="950">
+                <a:solidFill>
+                  <a:srgbClr val="BE123C"/>
+                </a:solidFill>
+              </a:rPr>
+              <a:t>R7 — Preservação de Máscaras: </a:t>
+            </a:r>
+            <a:r>
+              <a:rPr sz="900">
+                <a:solidFill>
+                  <a:srgbClr val="0F172A"/>
+                </a:solidFill>
+              </a:rPr>
+              <a:t>Nuvens e sombras mantidas como lacunas reais.</a:t>
+            </a:r>
+          </a:p>
+          <a:p>
+            <a:pPr>
+              <a:spcAft>
+                <a:spcPts val="200"/>
+              </a:spcAft>
+            </a:pPr>
+            <a:r>
+              <a:rPr b="1" sz="950">
+                <a:solidFill>
+                  <a:srgbClr val="BE123C"/>
+                </a:solidFill>
+              </a:rPr>
+              <a:t>R8 — Evidência de Verificação: </a:t>
+            </a:r>
+            <a:r>
+              <a:rPr sz="900">
+                <a:solidFill>
+                  <a:srgbClr val="0F172A"/>
+                </a:solidFill>
+              </a:rPr>
+              <a:t>Asserções exigem arquivos físicos de prova.</a:t>
+            </a:r>
+          </a:p>
+          <a:p>
+            <a:pPr>
+              <a:spcAft>
+                <a:spcPts val="200"/>
+              </a:spcAft>
+            </a:pPr>
+            <a:r>
+              <a:rPr b="1" sz="950">
+                <a:solidFill>
+                  <a:srgbClr val="BE123C"/>
+                </a:solidFill>
+              </a:rPr>
+              <a:t>R9 — Preservação Histórica: </a:t>
+            </a:r>
+            <a:r>
+              <a:rPr sz="900">
+                <a:solidFill>
+                  <a:srgbClr val="0F172A"/>
+                </a:solidFill>
+              </a:rPr>
+              <a:t>Rastreabilidade e integridade via branch sarel/v2.</a:t>
             </a:r>
           </a:p>
         </p:txBody>
@@ -6386,8 +6340,8 @@
         </p:nvSpPr>
         <p:spPr>
           <a:xfrm>
-            <a:off x="6217920" y="1371600"/>
-            <a:ext cx="5257800" cy="4846320"/>
+            <a:off x="6217920" y="1280160"/>
+            <a:ext cx="5257800" cy="4937760"/>
           </a:xfrm>
           <a:prstGeom prst="roundRect">
             <a:avLst/>
@@ -6397,7 +6351,7 @@
           </a:solidFill>
           <a:ln>
             <a:solidFill>
-              <a:srgbClr val="059669"/>
+              <a:srgbClr val="065F46"/>
             </a:solidFill>
           </a:ln>
         </p:spPr>
@@ -6431,8 +6385,8 @@
         </p:nvSpPr>
         <p:spPr>
           <a:xfrm>
-            <a:off x="6400800" y="1463040"/>
-            <a:ext cx="4892040" cy="4572000"/>
+            <a:off x="6400800" y="1371600"/>
+            <a:ext cx="4892040" cy="4663440"/>
           </a:xfrm>
           <a:prstGeom prst="rect">
             <a:avLst/>
@@ -6447,108 +6401,177 @@
           <a:p>
             <a:pPr>
               <a:spcAft>
-                <a:spcPts val="800"/>
+                <a:spcPts val="600"/>
               </a:spcAft>
-              <a:defRPr b="1" sz="1300">
+              <a:defRPr b="1" sz="1200">
                 <a:solidFill>
                   <a:srgbClr val="065F46"/>
                 </a:solidFill>
               </a:defRPr>
             </a:pPr>
             <a:r>
-              <a:t>MODELO P — PROGNÓSTICO PREDITIVO PREVENTIVO</a:t>
+              <a:t>OS 7 INVARIANTES DE INTEGRIDADE COMPUTACIONAL</a:t>
             </a:r>
           </a:p>
           <a:p>
             <a:pPr>
               <a:spcAft>
-                <a:spcPts val="800"/>
+                <a:spcPts val="400"/>
               </a:spcAft>
             </a:pPr>
             <a:r>
-              <a:rPr b="1" sz="1000">
+              <a:rPr b="1" sz="950">
                 <a:solidFill>
                   <a:srgbClr val="065F46"/>
                 </a:solidFill>
               </a:rPr>
-              <a:t>• Finalidade Operacional: </a:t>
-            </a:r>
-            <a:r>
-              <a:rPr sz="950">
+              <a:t>Invariante 1: </a:t>
+            </a:r>
+            <a:r>
+              <a:rPr sz="900">
                 <a:solidFill>
                   <a:srgbClr val="0F172A"/>
                 </a:solidFill>
               </a:rPr>
-              <a:t>Prever o RISCO FUTURO de surgimento de erosão laminar antes que a feição física se manifeste em superfície.</a:t>
+              <a:t>RUSLE completa: perdaSolo &lt;=&gt; 5 fatores presentes &lt;=&gt; memória cálculo.</a:t>
             </a:r>
           </a:p>
           <a:p>
             <a:pPr>
               <a:spcAft>
-                <a:spcPts val="800"/>
+                <a:spcPts val="400"/>
               </a:spcAft>
             </a:pPr>
             <a:r>
-              <a:rPr b="1" sz="1000">
+              <a:rPr b="1" sz="950">
                 <a:solidFill>
                   <a:srgbClr val="065F46"/>
                 </a:solidFill>
               </a:rPr>
-              <a:t>• Guarda Temporal Bienal (D04): </a:t>
-            </a:r>
-            <a:r>
-              <a:rPr sz="950">
+              <a:t>Invariante 2: </a:t>
+            </a:r>
+            <a:r>
+              <a:rPr sz="900">
                 <a:solidFill>
                   <a:srgbClr val="0F172A"/>
                 </a:solidFill>
               </a:rPr>
-              <a:t>Janela de guarda mandatória de 24 meses (2 anos) antes de t0 (Kaufman et al., 2012 / Embrapa Soja), eliminando data leakage.</a:t>
+              <a:t>Lista de permissão estrita: bloqueia vazamento de Phi_diag ou coordenadas.</a:t>
             </a:r>
           </a:p>
           <a:p>
             <a:pPr>
               <a:spcAft>
-                <a:spcPts val="800"/>
+                <a:spcPts val="400"/>
               </a:spcAft>
             </a:pPr>
             <a:r>
-              <a:rPr b="1" sz="1000">
+              <a:rPr b="1" sz="950">
                 <a:solidFill>
                   <a:srgbClr val="065F46"/>
                 </a:solidFill>
               </a:rPr>
-              <a:t>• Assinatura Biofísica: </a:t>
-            </a:r>
-            <a:r>
-              <a:rPr sz="950">
+              <a:t>Invariante 3: </a:t>
+            </a:r>
+            <a:r>
+              <a:rPr sz="900">
                 <a:solidFill>
                   <a:srgbClr val="0F172A"/>
                 </a:solidFill>
               </a:rPr>
-              <a:t>Identifica fraquezas estruturais de manejo histórico (ausência de rotação, baixa biomassa prévia, alta frequência de solo nu).</a:t>
+              <a:t>Campos estimados derivados rigorosamente de estados não medidos.</a:t>
             </a:r>
           </a:p>
           <a:p>
             <a:pPr>
               <a:spcAft>
-                <a:spcPts val="800"/>
+                <a:spcPts val="400"/>
               </a:spcAft>
             </a:pPr>
             <a:r>
-              <a:rPr b="1" sz="1000">
+              <a:rPr b="1" sz="950">
                 <a:solidFill>
                   <a:srgbClr val="065F46"/>
                 </a:solidFill>
               </a:rPr>
-              <a:t>• Aplicação Prática: </a:t>
-            </a:r>
-            <a:r>
-              <a:rPr sz="950">
+              <a:t>Invariante 4: </a:t>
+            </a:r>
+            <a:r>
+              <a:rPr sz="900">
                 <a:solidFill>
                   <a:srgbClr val="0F172A"/>
                 </a:solidFill>
               </a:rPr>
-              <a:t>Planejamento conservacionista preditivo, crédito rural sustentável, subsídio para apólices de seguro agrícola e manejo preventivo de bacias.</a:t>
+              <a:t>Rastreabilidade orbital: exigência de PRODUCT_ID, motor e timestamp.</a:t>
+            </a:r>
+          </a:p>
+          <a:p>
+            <a:pPr>
+              <a:spcAft>
+                <a:spcPts val="400"/>
+              </a:spcAft>
+            </a:pPr>
+            <a:r>
+              <a:rPr b="1" sz="950">
+                <a:solidFill>
+                  <a:srgbClr val="065F46"/>
+                </a:solidFill>
+              </a:rPr>
+              <a:t>Invariante 5: </a:t>
+            </a:r>
+            <a:r>
+              <a:rPr sz="900">
+                <a:solidFill>
+                  <a:srgbClr val="0F172A"/>
+                </a:solidFill>
+              </a:rPr>
+              <a:t>Afirmação negativa fundiária: exige histórico sem match geográfico.</a:t>
+            </a:r>
+          </a:p>
+          <a:p>
+            <a:pPr>
+              <a:spcAft>
+                <a:spcPts val="400"/>
+              </a:spcAft>
+            </a:pPr>
+            <a:r>
+              <a:rPr b="1" sz="950">
+                <a:solidFill>
+                  <a:srgbClr val="065F46"/>
+                </a:solidFill>
+              </a:rPr>
+              <a:t>Invariante 6: </a:t>
+            </a:r>
+            <a:r>
+              <a:rPr sz="900">
+                <a:solidFill>
+                  <a:srgbClr val="0F172A"/>
+                </a:solidFill>
+              </a:rPr>
+              <a:t>Proibição de literais espúrios ('Custom', 'Bacia Local', etc.).</a:t>
+            </a:r>
+          </a:p>
+          <a:p>
+            <a:pPr>
+              <a:spcAft>
+                <a:spcPts val="400"/>
+              </a:spcAft>
+            </a:pPr>
+            <a:r>
+              <a:rPr b="1" sz="950">
+                <a:solidFill>
+                  <a:srgbClr val="065F46"/>
+                </a:solidFill>
+              </a:rPr>
+              <a:t>Invariante 7: </a:t>
+            </a:r>
+            <a:r>
+              <a:rPr sz="900">
+                <a:solidFill>
+                  <a:srgbClr val="0F172A"/>
+                </a:solidFill>
+              </a:rPr>
+              <a:t>Detector de constante disfarçada: recusa colunas numéricas estáticas.</a:t>
             </a:r>
           </a:p>
         </p:txBody>
@@ -6689,7 +6712,7 @@
               </a:defRPr>
             </a:pPr>
             <a:r>
-              <a:t>14. Referências Bibliográficas (Normas ABNT NBR 6023:2018) — Parte 1</a:t>
+              <a:t>14. Segregação Temporal: Modelo D vs. Modelo P</a:t>
             </a:r>
           </a:p>
         </p:txBody>
@@ -6782,8 +6805,8 @@
         </p:nvSpPr>
         <p:spPr>
           <a:xfrm>
-            <a:off x="731520" y="1280160"/>
-            <a:ext cx="10728655" cy="4937760"/>
+            <a:off x="731520" y="1371600"/>
+            <a:ext cx="5257800" cy="4846320"/>
           </a:xfrm>
           <a:prstGeom prst="roundRect">
             <a:avLst/>
@@ -6793,7 +6816,7 @@
           </a:solidFill>
           <a:ln>
             <a:solidFill>
-              <a:srgbClr val="E2E8F0"/>
+              <a:srgbClr val="0EA5E9"/>
             </a:solidFill>
           </a:ln>
         </p:spPr>
@@ -6827,8 +6850,8 @@
         </p:nvSpPr>
         <p:spPr>
           <a:xfrm>
-            <a:off x="1005840" y="1371600"/>
-            <a:ext cx="10149840" cy="4663440"/>
+            <a:off x="914400" y="1463040"/>
+            <a:ext cx="4892040" cy="4572000"/>
           </a:xfrm>
           <a:prstGeom prst="rect">
             <a:avLst/>
@@ -6843,106 +6866,283 @@
           <a:p>
             <a:pPr>
               <a:spcAft>
-                <a:spcPts val="1000"/>
+                <a:spcPts val="800"/>
               </a:spcAft>
-              <a:defRPr sz="1000">
+              <a:defRPr b="1" sz="1300">
+                <a:solidFill>
+                  <a:srgbClr val="0369A1"/>
+                </a:solidFill>
+              </a:defRPr>
+            </a:pPr>
+            <a:r>
+              <a:t>MODELO D — DETECÇÃO CONTEMPORÂNEA</a:t>
+            </a:r>
+          </a:p>
+          <a:p>
+            <a:pPr>
+              <a:spcAft>
+                <a:spcPts val="800"/>
+              </a:spcAft>
+            </a:pPr>
+            <a:r>
+              <a:rPr b="1" sz="1000">
+                <a:solidFill>
+                  <a:srgbClr val="0369A1"/>
+                </a:solidFill>
+              </a:rPr>
+              <a:t>• Finalidade Operacional: </a:t>
+            </a:r>
+            <a:r>
+              <a:rPr sz="950">
                 <a:solidFill>
                   <a:srgbClr val="0F172A"/>
                 </a:solidFill>
-              </a:defRPr>
-            </a:pPr>
-            <a:r>
-              <a:t>• COELHO, M. R. et al. Erodibilidade dos solos do Brasil. Rio de Janeiro: Embrapa Solos, 2024. 38 p. (Documentos / Embrapa Solos, n. 246). Disponível em: http://www.infoteca.cnptia.embrapa.br/infoteca/handle/doc/1170044.</a:t>
+              </a:rPr>
+              <a:t>Mapear feições de erosão laminar que JÁ se manifestaram visualmente no terreno (diagnóstico pericial contemporâneo).</a:t>
             </a:r>
           </a:p>
           <a:p>
             <a:pPr>
               <a:spcAft>
-                <a:spcPts val="1000"/>
+                <a:spcPts val="800"/>
               </a:spcAft>
-              <a:defRPr sz="1000">
+            </a:pPr>
+            <a:r>
+              <a:rPr b="1" sz="1000">
+                <a:solidFill>
+                  <a:srgbClr val="0369A1"/>
+                </a:solidFill>
+              </a:rPr>
+              <a:t>• Extensão da Janela Temporal: </a:t>
+            </a:r>
+            <a:r>
+              <a:rPr sz="950">
                 <a:solidFill>
                   <a:srgbClr val="0F172A"/>
                 </a:solidFill>
-              </a:defRPr>
-            </a:pPr>
-            <a:r>
-              <a:t>• CHEN, T.; GUESTRIN, C. XGBoost: A Scalable Tree Boosting System. In: ACM SIGKDD INTERNATIONAL CONFERENCE ON KNOWLEDGE DISCOVERY AND DATA MINING, 22., 2016, San Francisco. Proceedings [...]. New York: ACM, 2016. p. 785–794.</a:t>
+              </a:rPr>
+              <a:t>Série temporal orbitando continuamente até a data exata do evento ou inspeção pericial (t0).</a:t>
             </a:r>
           </a:p>
           <a:p>
             <a:pPr>
               <a:spcAft>
-                <a:spcPts val="1000"/>
+                <a:spcPts val="800"/>
               </a:spcAft>
-              <a:defRPr sz="1000">
+            </a:pPr>
+            <a:r>
+              <a:rPr b="1" sz="1000">
+                <a:solidFill>
+                  <a:srgbClr val="0369A1"/>
+                </a:solidFill>
+              </a:rPr>
+              <a:t>• Assinatura Biofísica: </a:t>
+            </a:r>
+            <a:r>
+              <a:rPr sz="950">
                 <a:solidFill>
                   <a:srgbClr val="0F172A"/>
                 </a:solidFill>
-              </a:defRPr>
-            </a:pPr>
-            <a:r>
-              <a:t>• DEMATTÊ, J. A. M. et al. Geospatial Soil Sensing System (GEOS3): A powerful data mining procedure to retrieve soil spectral reflectance from satellite images. Remote Sensing of Environment, v. 212, p. 161–175, 2018.</a:t>
+              </a:rPr>
+              <a:t>Detecta horizonte B exposto, BSI &gt; 0.10, redução drástica de biomassa e empobrecimento em carbono orgânico.</a:t>
             </a:r>
           </a:p>
           <a:p>
             <a:pPr>
               <a:spcAft>
-                <a:spcPts val="1000"/>
+                <a:spcPts val="800"/>
               </a:spcAft>
-              <a:defRPr sz="1000">
+            </a:pPr>
+            <a:r>
+              <a:rPr b="1" sz="1000">
+                <a:solidFill>
+                  <a:srgbClr val="0369A1"/>
+                </a:solidFill>
+              </a:rPr>
+              <a:t>• Aplicação Prática: </a:t>
+            </a:r>
+            <a:r>
+              <a:rPr sz="950">
                 <a:solidFill>
                   <a:srgbClr val="0F172A"/>
                 </a:solidFill>
-              </a:defRPr>
-            </a:pPr>
-            <a:r>
-              <a:t>• DURIGON, V. L. et al. NDVI-based C-factor estimation for RUSLE in Brazilian watersheds. Revista Brasileira de Ciência do Solo, v. 38, n. 3, p. 726–734, 2014.</a:t>
-            </a:r>
-          </a:p>
+              </a:rPr>
+              <a:t>Perícia judicial ambiental, fiscalização agropecuária, apuração de responsabilidade por degradação e autuações.</a:t>
+            </a:r>
+          </a:p>
+        </p:txBody>
+      </p:sp>
+      <p:sp>
+        <p:nvSpPr>
+          <p:cNvPr id="9" name="Rounded Rectangle 8"/>
+          <p:cNvSpPr/>
+          <p:nvPr/>
+        </p:nvSpPr>
+        <p:spPr>
+          <a:xfrm>
+            <a:off x="6217920" y="1371600"/>
+            <a:ext cx="5257800" cy="4846320"/>
+          </a:xfrm>
+          <a:prstGeom prst="roundRect">
+            <a:avLst/>
+          </a:prstGeom>
+          <a:solidFill>
+            <a:srgbClr val="FFFFFF"/>
+          </a:solidFill>
+          <a:ln>
+            <a:solidFill>
+              <a:srgbClr val="059669"/>
+            </a:solidFill>
+          </a:ln>
+        </p:spPr>
+        <p:style>
+          <a:lnRef idx="1">
+            <a:schemeClr val="accent1"/>
+          </a:lnRef>
+          <a:fillRef idx="3">
+            <a:schemeClr val="accent1"/>
+          </a:fillRef>
+          <a:effectRef idx="2">
+            <a:schemeClr val="accent1"/>
+          </a:effectRef>
+          <a:fontRef idx="minor">
+            <a:schemeClr val="lt1"/>
+          </a:fontRef>
+        </p:style>
+        <p:txBody>
+          <a:bodyPr rtlCol="0" anchor="ctr"/>
+          <a:lstStyle/>
+          <a:p>
+            <a:pPr algn="ctr"/>
+          </a:p>
+        </p:txBody>
+      </p:sp>
+      <p:sp>
+        <p:nvSpPr>
+          <p:cNvPr id="10" name="TextBox 9"/>
+          <p:cNvSpPr txBox="1"/>
+          <p:nvPr/>
+        </p:nvSpPr>
+        <p:spPr>
+          <a:xfrm>
+            <a:off x="6400800" y="1463040"/>
+            <a:ext cx="4892040" cy="4572000"/>
+          </a:xfrm>
+          <a:prstGeom prst="rect">
+            <a:avLst/>
+          </a:prstGeom>
+          <a:noFill/>
+        </p:spPr>
+        <p:txBody>
+          <a:bodyPr wrap="square">
+            <a:spAutoFit/>
+          </a:bodyPr>
+          <a:lstStyle/>
           <a:p>
             <a:pPr>
               <a:spcAft>
-                <a:spcPts val="1000"/>
+                <a:spcPts val="800"/>
               </a:spcAft>
-              <a:defRPr sz="1000">
+              <a:defRPr b="1" sz="1300">
+                <a:solidFill>
+                  <a:srgbClr val="065F46"/>
+                </a:solidFill>
+              </a:defRPr>
+            </a:pPr>
+            <a:r>
+              <a:t>MODELO P — PROGNÓSTICO PREDITIVO PREVENTIVO</a:t>
+            </a:r>
+          </a:p>
+          <a:p>
+            <a:pPr>
+              <a:spcAft>
+                <a:spcPts val="800"/>
+              </a:spcAft>
+            </a:pPr>
+            <a:r>
+              <a:rPr b="1" sz="1000">
+                <a:solidFill>
+                  <a:srgbClr val="065F46"/>
+                </a:solidFill>
+              </a:rPr>
+              <a:t>• Finalidade Operacional: </a:t>
+            </a:r>
+            <a:r>
+              <a:rPr sz="950">
                 <a:solidFill>
                   <a:srgbClr val="0F172A"/>
                 </a:solidFill>
-              </a:defRPr>
-            </a:pPr>
-            <a:r>
-              <a:t>• KARYDAS, C. G.; PANAGOS, P. The G2 erosion model: month-time step assessments at regional scale. Environmental Research, v. 161, p. 115–124, 2018.</a:t>
+              </a:rPr>
+              <a:t>Prever o RISCO FUTURO de surgimento de erosão laminar antes que a feição física se manifeste em superfície.</a:t>
             </a:r>
           </a:p>
           <a:p>
             <a:pPr>
               <a:spcAft>
-                <a:spcPts val="1000"/>
+                <a:spcPts val="800"/>
               </a:spcAft>
-              <a:defRPr sz="1000">
+            </a:pPr>
+            <a:r>
+              <a:rPr b="1" sz="1000">
+                <a:solidFill>
+                  <a:srgbClr val="065F46"/>
+                </a:solidFill>
+              </a:rPr>
+              <a:t>• Guarda Temporal Bienal (D04): </a:t>
+            </a:r>
+            <a:r>
+              <a:rPr sz="950">
                 <a:solidFill>
                   <a:srgbClr val="0F172A"/>
                 </a:solidFill>
-              </a:defRPr>
-            </a:pPr>
-            <a:r>
-              <a:t>• KAUFMAN, S. et al. Leakage in data mining: formulation, detection, and avoidance. ACM Transactions on Knowledge Discovery from Data (TKDD), v. 6, n. 4, p. 1–21, 2012.</a:t>
+              </a:rPr>
+              <a:t>Janela de guarda mandatória de 24 meses (2 anos) antes de t0 (Kaufman et al., 2012 / Embrapa Soja), eliminando data leakage.</a:t>
             </a:r>
           </a:p>
           <a:p>
             <a:pPr>
               <a:spcAft>
-                <a:spcPts val="1000"/>
+                <a:spcPts val="800"/>
               </a:spcAft>
-              <a:defRPr sz="1000">
+            </a:pPr>
+            <a:r>
+              <a:rPr b="1" sz="1000">
+                <a:solidFill>
+                  <a:srgbClr val="065F46"/>
+                </a:solidFill>
+              </a:rPr>
+              <a:t>• Assinatura Biofísica: </a:t>
+            </a:r>
+            <a:r>
+              <a:rPr sz="950">
                 <a:solidFill>
                   <a:srgbClr val="0F172A"/>
                 </a:solidFill>
-              </a:defRPr>
-            </a:pPr>
-            <a:r>
-              <a:t>• LANDIS, J. R.; KOCH, G. G. The measurement of observer agreement for categorical data. Biometrics, v. 33, n. 1, p. 159–174, 1977.</a:t>
+              </a:rPr>
+              <a:t>Identifica fraquezas estruturais de manejo histórico (ausência de rotação, baixa biomassa prévia, alta frequência de solo nu).</a:t>
+            </a:r>
+          </a:p>
+          <a:p>
+            <a:pPr>
+              <a:spcAft>
+                <a:spcPts val="800"/>
+              </a:spcAft>
+            </a:pPr>
+            <a:r>
+              <a:rPr b="1" sz="1000">
+                <a:solidFill>
+                  <a:srgbClr val="065F46"/>
+                </a:solidFill>
+              </a:rPr>
+              <a:t>• Aplicação Prática: </a:t>
+            </a:r>
+            <a:r>
+              <a:rPr sz="950">
+                <a:solidFill>
+                  <a:srgbClr val="0F172A"/>
+                </a:solidFill>
+              </a:rPr>
+              <a:t>Planejamento conservacionista preditivo, crédito rural sustentável, subsídio para apólices de seguro agrícola e manejo preventivo de bacias.</a:t>
             </a:r>
           </a:p>
         </p:txBody>
@@ -7083,7 +7283,7 @@
               </a:defRPr>
             </a:pPr>
             <a:r>
-              <a:t>15. Referências Bibliográficas (Normas ABNT NBR 6023:2018) — Parte 2</a:t>
+              <a:t>15. Referências Bibliográficas (Normas ABNT NBR 6023:2018) — Parte 1</a:t>
             </a:r>
           </a:p>
         </p:txBody>
@@ -7164,6 +7364,400 @@
             </a:pPr>
             <a:r>
               <a:t>SAREL v2.0 • Sistema de Amostragem e Rotulagem para Erosão Laminar | UTFPR Medianeira | Slide 16 de 16</a:t>
+            </a:r>
+          </a:p>
+        </p:txBody>
+      </p:sp>
+      <p:sp>
+        <p:nvSpPr>
+          <p:cNvPr id="7" name="Rounded Rectangle 6"/>
+          <p:cNvSpPr/>
+          <p:nvPr/>
+        </p:nvSpPr>
+        <p:spPr>
+          <a:xfrm>
+            <a:off x="731520" y="1280160"/>
+            <a:ext cx="10728655" cy="4937760"/>
+          </a:xfrm>
+          <a:prstGeom prst="roundRect">
+            <a:avLst/>
+          </a:prstGeom>
+          <a:solidFill>
+            <a:srgbClr val="FFFFFF"/>
+          </a:solidFill>
+          <a:ln>
+            <a:solidFill>
+              <a:srgbClr val="E2E8F0"/>
+            </a:solidFill>
+          </a:ln>
+        </p:spPr>
+        <p:style>
+          <a:lnRef idx="1">
+            <a:schemeClr val="accent1"/>
+          </a:lnRef>
+          <a:fillRef idx="3">
+            <a:schemeClr val="accent1"/>
+          </a:fillRef>
+          <a:effectRef idx="2">
+            <a:schemeClr val="accent1"/>
+          </a:effectRef>
+          <a:fontRef idx="minor">
+            <a:schemeClr val="lt1"/>
+          </a:fontRef>
+        </p:style>
+        <p:txBody>
+          <a:bodyPr rtlCol="0" anchor="ctr"/>
+          <a:lstStyle/>
+          <a:p>
+            <a:pPr algn="ctr"/>
+          </a:p>
+        </p:txBody>
+      </p:sp>
+      <p:sp>
+        <p:nvSpPr>
+          <p:cNvPr id="8" name="TextBox 7"/>
+          <p:cNvSpPr txBox="1"/>
+          <p:nvPr/>
+        </p:nvSpPr>
+        <p:spPr>
+          <a:xfrm>
+            <a:off x="1005840" y="1371600"/>
+            <a:ext cx="10149840" cy="4663440"/>
+          </a:xfrm>
+          <a:prstGeom prst="rect">
+            <a:avLst/>
+          </a:prstGeom>
+          <a:noFill/>
+        </p:spPr>
+        <p:txBody>
+          <a:bodyPr wrap="square">
+            <a:spAutoFit/>
+          </a:bodyPr>
+          <a:lstStyle/>
+          <a:p>
+            <a:pPr>
+              <a:spcAft>
+                <a:spcPts val="1000"/>
+              </a:spcAft>
+              <a:defRPr sz="1000">
+                <a:solidFill>
+                  <a:srgbClr val="0F172A"/>
+                </a:solidFill>
+              </a:defRPr>
+            </a:pPr>
+            <a:r>
+              <a:t>• COELHO, M. R. et al. Erodibilidade dos solos do Brasil. Rio de Janeiro: Embrapa Solos, 2024. 38 p. (Documentos / Embrapa Solos, n. 246). Disponível em: http://www.infoteca.cnptia.embrapa.br/infoteca/handle/doc/1170044.</a:t>
+            </a:r>
+          </a:p>
+          <a:p>
+            <a:pPr>
+              <a:spcAft>
+                <a:spcPts val="1000"/>
+              </a:spcAft>
+              <a:defRPr sz="1000">
+                <a:solidFill>
+                  <a:srgbClr val="0F172A"/>
+                </a:solidFill>
+              </a:defRPr>
+            </a:pPr>
+            <a:r>
+              <a:t>• CHEN, T.; GUESTRIN, C. XGBoost: A Scalable Tree Boosting System. In: ACM SIGKDD INTERNATIONAL CONFERENCE ON KNOWLEDGE DISCOVERY AND DATA MINING, 22., 2016, San Francisco. Proceedings [...]. New York: ACM, 2016. p. 785–794.</a:t>
+            </a:r>
+          </a:p>
+          <a:p>
+            <a:pPr>
+              <a:spcAft>
+                <a:spcPts val="1000"/>
+              </a:spcAft>
+              <a:defRPr sz="1000">
+                <a:solidFill>
+                  <a:srgbClr val="0F172A"/>
+                </a:solidFill>
+              </a:defRPr>
+            </a:pPr>
+            <a:r>
+              <a:t>• DEMATTÊ, J. A. M. et al. Geospatial Soil Sensing System (GEOS3): A powerful data mining procedure to retrieve soil spectral reflectance from satellite images. Remote Sensing of Environment, v. 212, p. 161–175, 2018.</a:t>
+            </a:r>
+          </a:p>
+          <a:p>
+            <a:pPr>
+              <a:spcAft>
+                <a:spcPts val="1000"/>
+              </a:spcAft>
+              <a:defRPr sz="1000">
+                <a:solidFill>
+                  <a:srgbClr val="0F172A"/>
+                </a:solidFill>
+              </a:defRPr>
+            </a:pPr>
+            <a:r>
+              <a:t>• DURIGON, V. L. et al. NDVI-based C-factor estimation for RUSLE in Brazilian watersheds. Revista Brasileira de Ciência do Solo, v. 38, n. 3, p. 726–734, 2014.</a:t>
+            </a:r>
+          </a:p>
+          <a:p>
+            <a:pPr>
+              <a:spcAft>
+                <a:spcPts val="1000"/>
+              </a:spcAft>
+              <a:defRPr sz="1000">
+                <a:solidFill>
+                  <a:srgbClr val="0F172A"/>
+                </a:solidFill>
+              </a:defRPr>
+            </a:pPr>
+            <a:r>
+              <a:t>• KARYDAS, C. G.; PANAGOS, P. The G2 erosion model: month-time step assessments at regional scale. Environmental Research, v. 161, p. 115–124, 2018.</a:t>
+            </a:r>
+          </a:p>
+          <a:p>
+            <a:pPr>
+              <a:spcAft>
+                <a:spcPts val="1000"/>
+              </a:spcAft>
+              <a:defRPr sz="1000">
+                <a:solidFill>
+                  <a:srgbClr val="0F172A"/>
+                </a:solidFill>
+              </a:defRPr>
+            </a:pPr>
+            <a:r>
+              <a:t>• KAUFMAN, S. et al. Leakage in data mining: formulation, detection, and avoidance. ACM Transactions on Knowledge Discovery from Data (TKDD), v. 6, n. 4, p. 1–21, 2012.</a:t>
+            </a:r>
+          </a:p>
+          <a:p>
+            <a:pPr>
+              <a:spcAft>
+                <a:spcPts val="1000"/>
+              </a:spcAft>
+              <a:defRPr sz="1000">
+                <a:solidFill>
+                  <a:srgbClr val="0F172A"/>
+                </a:solidFill>
+              </a:defRPr>
+            </a:pPr>
+            <a:r>
+              <a:t>• LANDIS, J. R.; KOCH, G. G. The measurement of observer agreement for categorical data. Biometrics, v. 33, n. 1, p. 159–174, 1977.</a:t>
+            </a:r>
+          </a:p>
+        </p:txBody>
+      </p:sp>
+    </p:spTree>
+  </p:cSld>
+  <p:clrMapOvr>
+    <a:masterClrMapping/>
+  </p:clrMapOvr>
+</p:sld>
+</file>
+
+<file path=ppt/slides/slide17.xml><?xml version="1.0" encoding="utf-8"?>
+<p:sld xmlns:a="http://schemas.openxmlformats.org/drawingml/2006/main" xmlns:p="http://schemas.openxmlformats.org/presentationml/2006/main" xmlns:r="http://schemas.openxmlformats.org/officeDocument/2006/relationships">
+  <p:cSld>
+    <p:bg>
+      <p:bgPr>
+        <a:solidFill>
+          <a:srgbClr val="F8FAFC"/>
+        </a:solidFill>
+        <a:effectLst/>
+      </p:bgPr>
+    </p:bg>
+    <p:spTree>
+      <p:nvGrpSpPr>
+        <p:cNvPr id="1" name=""/>
+        <p:cNvGrpSpPr/>
+        <p:nvPr/>
+      </p:nvGrpSpPr>
+      <p:grpSpPr/>
+      <p:sp>
+        <p:nvSpPr>
+          <p:cNvPr id="2" name="Rectangle 1"/>
+          <p:cNvSpPr/>
+          <p:nvPr/>
+        </p:nvSpPr>
+        <p:spPr>
+          <a:xfrm>
+            <a:off x="0" y="0"/>
+            <a:ext cx="12191695" cy="1051560"/>
+          </a:xfrm>
+          <a:prstGeom prst="rect">
+            <a:avLst/>
+          </a:prstGeom>
+          <a:solidFill>
+            <a:srgbClr val="0F172A"/>
+          </a:solidFill>
+          <a:ln>
+            <a:solidFill>
+              <a:srgbClr val="0F172A"/>
+            </a:solidFill>
+          </a:ln>
+        </p:spPr>
+        <p:style>
+          <a:lnRef idx="1">
+            <a:schemeClr val="accent1"/>
+          </a:lnRef>
+          <a:fillRef idx="3">
+            <a:schemeClr val="accent1"/>
+          </a:fillRef>
+          <a:effectRef idx="2">
+            <a:schemeClr val="accent1"/>
+          </a:effectRef>
+          <a:fontRef idx="minor">
+            <a:schemeClr val="lt1"/>
+          </a:fontRef>
+        </p:style>
+        <p:txBody>
+          <a:bodyPr rtlCol="0" anchor="ctr"/>
+          <a:lstStyle/>
+          <a:p>
+            <a:pPr algn="ctr"/>
+          </a:p>
+        </p:txBody>
+      </p:sp>
+      <p:sp>
+        <p:nvSpPr>
+          <p:cNvPr id="3" name="TextBox 2"/>
+          <p:cNvSpPr txBox="1"/>
+          <p:nvPr/>
+        </p:nvSpPr>
+        <p:spPr>
+          <a:xfrm>
+            <a:off x="731520" y="109728"/>
+            <a:ext cx="10698480" cy="274320"/>
+          </a:xfrm>
+          <a:prstGeom prst="rect">
+            <a:avLst/>
+          </a:prstGeom>
+          <a:noFill/>
+        </p:spPr>
+        <p:txBody>
+          <a:bodyPr wrap="none">
+            <a:spAutoFit/>
+          </a:bodyPr>
+          <a:lstStyle/>
+          <a:p>
+            <a:pPr>
+              <a:defRPr sz="950" b="1">
+                <a:solidFill>
+                  <a:srgbClr val="10B981"/>
+                </a:solidFill>
+              </a:defRPr>
+            </a:pPr>
+            <a:r>
+              <a:t>PPGTCA 2026 • PESQUISA DE MESTRADO EM EROSÃO LAMINAR (UTFPR)</a:t>
+            </a:r>
+          </a:p>
+        </p:txBody>
+      </p:sp>
+      <p:sp>
+        <p:nvSpPr>
+          <p:cNvPr id="4" name="TextBox 3"/>
+          <p:cNvSpPr txBox="1"/>
+          <p:nvPr/>
+        </p:nvSpPr>
+        <p:spPr>
+          <a:xfrm>
+            <a:off x="731520" y="365760"/>
+            <a:ext cx="10698480" cy="548640"/>
+          </a:xfrm>
+          <a:prstGeom prst="rect">
+            <a:avLst/>
+          </a:prstGeom>
+          <a:noFill/>
+        </p:spPr>
+        <p:txBody>
+          <a:bodyPr wrap="none">
+            <a:spAutoFit/>
+          </a:bodyPr>
+          <a:lstStyle/>
+          <a:p>
+            <a:pPr>
+              <a:defRPr sz="2000" b="1">
+                <a:solidFill>
+                  <a:srgbClr val="FFFFFF"/>
+                </a:solidFill>
+              </a:defRPr>
+            </a:pPr>
+            <a:r>
+              <a:t>16. Referências Bibliográficas (Normas ABNT NBR 6023:2018) — Parte 2</a:t>
+            </a:r>
+          </a:p>
+        </p:txBody>
+      </p:sp>
+      <p:sp>
+        <p:nvSpPr>
+          <p:cNvPr id="5" name="Rectangle 4"/>
+          <p:cNvSpPr/>
+          <p:nvPr/>
+        </p:nvSpPr>
+        <p:spPr>
+          <a:xfrm>
+            <a:off x="0" y="1033271"/>
+            <a:ext cx="12191695" cy="36576"/>
+          </a:xfrm>
+          <a:prstGeom prst="rect">
+            <a:avLst/>
+          </a:prstGeom>
+          <a:solidFill>
+            <a:srgbClr val="059669"/>
+          </a:solidFill>
+          <a:ln>
+            <a:solidFill>
+              <a:srgbClr val="059669"/>
+            </a:solidFill>
+          </a:ln>
+        </p:spPr>
+        <p:style>
+          <a:lnRef idx="1">
+            <a:schemeClr val="accent1"/>
+          </a:lnRef>
+          <a:fillRef idx="3">
+            <a:schemeClr val="accent1"/>
+          </a:fillRef>
+          <a:effectRef idx="2">
+            <a:schemeClr val="accent1"/>
+          </a:effectRef>
+          <a:fontRef idx="minor">
+            <a:schemeClr val="lt1"/>
+          </a:fontRef>
+        </p:style>
+        <p:txBody>
+          <a:bodyPr rtlCol="0" anchor="ctr"/>
+          <a:lstStyle/>
+          <a:p>
+            <a:pPr algn="ctr"/>
+          </a:p>
+        </p:txBody>
+      </p:sp>
+      <p:sp>
+        <p:nvSpPr>
+          <p:cNvPr id="6" name="TextBox 5"/>
+          <p:cNvSpPr txBox="1"/>
+          <p:nvPr/>
+        </p:nvSpPr>
+        <p:spPr>
+          <a:xfrm>
+            <a:off x="731520" y="6492240"/>
+            <a:ext cx="10728655" cy="274320"/>
+          </a:xfrm>
+          <a:prstGeom prst="rect">
+            <a:avLst/>
+          </a:prstGeom>
+          <a:noFill/>
+        </p:spPr>
+        <p:txBody>
+          <a:bodyPr wrap="none">
+            <a:spAutoFit/>
+          </a:bodyPr>
+          <a:lstStyle/>
+          <a:p>
+            <a:pPr>
+              <a:defRPr sz="850">
+                <a:solidFill>
+                  <a:srgbClr val="475569"/>
+                </a:solidFill>
+              </a:defRPr>
+            </a:pPr>
+            <a:r>
+              <a:t>SAREL v2.0 • Sistema de Amostragem e Rotulagem para Erosão Laminar | UTFPR Medianeira | Slide 17 de 16</a:t>
             </a:r>
           </a:p>
         </p:txBody>

</xml_diff>

<commit_message>
feat: integrar vant multiespectral spectral 2 nuvem uav readequar p03 e atualizar documentacao
</commit_message>
<xml_diff>
--- a/docs/Apresentacao_SAREL_PPGTCA_2026.pptx
+++ b/docs/Apresentacao_SAREL_PPGTCA_2026.pptx
@@ -3461,7 +3461,7 @@
               </a:defRPr>
             </a:pPr>
             <a:r>
-              <a:t>SAREL v2.0 • Sistema de Amostragem e Rotulagem para Erosão Laminar | UTFPR Medianeira | Slide 10 de 16</a:t>
+              <a:t>SAREL v2.0 • Sistema de Amostragem e Rotulagem para Erosão Laminar | UTFPR Medianeira | Slide 10 de 17</a:t>
             </a:r>
           </a:p>
         </p:txBody>
@@ -3706,7 +3706,7 @@
               </a:defRPr>
             </a:pPr>
             <a:r>
-              <a:t>SAREL v2.0 • Sistema de Amostragem e Rotulagem para Erosão Laminar | UTFPR Medianeira | Slide 11 de 16</a:t>
+              <a:t>SAREL v2.0 • Sistema de Amostragem e Rotulagem para Erosão Laminar | UTFPR Medianeira | Slide 11 de 17</a:t>
             </a:r>
           </a:p>
         </p:txBody>
@@ -4483,7 +4483,7 @@
               </a:defRPr>
             </a:pPr>
             <a:r>
-              <a:t>SAREL v2.0 • Sistema de Amostragem e Rotulagem para Erosão Laminar | UTFPR Medianeira | Slide 12 de 16</a:t>
+              <a:t>SAREL v2.0 • Sistema de Amostragem e Rotulagem para Erosão Laminar | UTFPR Medianeira | Slide 12 de 17</a:t>
             </a:r>
           </a:p>
         </p:txBody>
@@ -5260,7 +5260,7 @@
               </a:defRPr>
             </a:pPr>
             <a:r>
-              <a:t>SAREL v2.0 • Sistema de Amostragem e Rotulagem para Erosão Laminar | UTFPR Medianeira | Slide 13 de 16</a:t>
+              <a:t>SAREL v2.0 • Sistema de Amostragem e Rotulagem para Erosão Laminar | UTFPR Medianeira | Slide 13 de 17</a:t>
             </a:r>
           </a:p>
         </p:txBody>
@@ -6037,7 +6037,7 @@
               </a:defRPr>
             </a:pPr>
             <a:r>
-              <a:t>SAREL v2.0 • Sistema de Amostragem e Rotulagem para Erosão Laminar | UTFPR Medianeira | Slide 14 de 16</a:t>
+              <a:t>SAREL v2.0 • Sistema de Amostragem e Rotulagem para Erosão Laminar | UTFPR Medianeira | Slide 14 de 17</a:t>
             </a:r>
           </a:p>
         </p:txBody>
@@ -6792,7 +6792,7 @@
               </a:defRPr>
             </a:pPr>
             <a:r>
-              <a:t>SAREL v2.0 • Sistema de Amostragem e Rotulagem para Erosão Laminar | UTFPR Medianeira | Slide 15 de 16</a:t>
+              <a:t>SAREL v2.0 • Sistema de Amostragem e Rotulagem para Erosão Laminar | UTFPR Medianeira | Slide 15 de 17</a:t>
             </a:r>
           </a:p>
         </p:txBody>
@@ -7363,7 +7363,7 @@
               </a:defRPr>
             </a:pPr>
             <a:r>
-              <a:t>SAREL v2.0 • Sistema de Amostragem e Rotulagem para Erosão Laminar | UTFPR Medianeira | Slide 16 de 16</a:t>
+              <a:t>SAREL v2.0 • Sistema de Amostragem e Rotulagem para Erosão Laminar | UTFPR Medianeira | Slide 16 de 17</a:t>
             </a:r>
           </a:p>
         </p:txBody>
@@ -7757,7 +7757,7 @@
               </a:defRPr>
             </a:pPr>
             <a:r>
-              <a:t>SAREL v2.0 • Sistema de Amostragem e Rotulagem para Erosão Laminar | UTFPR Medianeira | Slide 17 de 16</a:t>
+              <a:t>SAREL v2.0 • Sistema de Amostragem e Rotulagem para Erosão Laminar | UTFPR Medianeira | Slide 17 de 17</a:t>
             </a:r>
           </a:p>
         </p:txBody>
@@ -7828,6 +7828,21 @@
             <a:spAutoFit/>
           </a:bodyPr>
           <a:lstStyle/>
+          <a:p>
+            <a:pPr>
+              <a:spcAft>
+                <a:spcPts val="1000"/>
+              </a:spcAft>
+              <a:defRPr sz="1000">
+                <a:solidFill>
+                  <a:srgbClr val="0F172A"/>
+                </a:solidFill>
+              </a:defRPr>
+            </a:pPr>
+            <a:r>
+              <a:t>• CONGALTON, R. G.; GREEN, K. Assessing the accuracy of remotely sensed data: principles and practices. 3. ed. Boca Raton: CRC Press, 2019. 348 p.</a:t>
+            </a:r>
+          </a:p>
           <a:p>
             <a:pPr>
               <a:spcAft>
@@ -8151,7 +8166,7 @@
               </a:defRPr>
             </a:pPr>
             <a:r>
-              <a:t>SAREL v2.0 • Sistema de Amostragem e Rotulagem para Erosão Laminar | UTFPR Medianeira | Slide 2 de 16</a:t>
+              <a:t>SAREL v2.0 • Sistema de Amostragem e Rotulagem para Erosão Laminar | UTFPR Medianeira | Slide 2 de 17</a:t>
             </a:r>
           </a:p>
         </p:txBody>
@@ -8932,7 +8947,7 @@
               </a:defRPr>
             </a:pPr>
             <a:r>
-              <a:t>SAREL v2.0 • Sistema de Amostragem e Rotulagem para Erosão Laminar | UTFPR Medianeira | Slide 3 de 16</a:t>
+              <a:t>SAREL v2.0 • Sistema de Amostragem e Rotulagem para Erosão Laminar | UTFPR Medianeira | Slide 3 de 17</a:t>
             </a:r>
           </a:p>
         </p:txBody>
@@ -9953,7 +9968,7 @@
               </a:defRPr>
             </a:pPr>
             <a:r>
-              <a:t>SAREL v2.0 • Sistema de Amostragem e Rotulagem para Erosão Laminar | UTFPR Medianeira | Slide 4 de 16</a:t>
+              <a:t>SAREL v2.0 • Sistema de Amostragem e Rotulagem para Erosão Laminar | UTFPR Medianeira | Slide 4 de 17</a:t>
             </a:r>
           </a:p>
         </p:txBody>
@@ -10671,7 +10686,7 @@
               </a:defRPr>
             </a:pPr>
             <a:r>
-              <a:t>SAREL v2.0 • Sistema de Amostragem e Rotulagem para Erosão Laminar | UTFPR Medianeira | Slide 5 de 16</a:t>
+              <a:t>SAREL v2.0 • Sistema de Amostragem e Rotulagem para Erosão Laminar | UTFPR Medianeira | Slide 5 de 17</a:t>
             </a:r>
           </a:p>
         </p:txBody>
@@ -11452,7 +11467,7 @@
               </a:defRPr>
             </a:pPr>
             <a:r>
-              <a:t>SAREL v2.0 • Sistema de Amostragem e Rotulagem para Erosão Laminar | UTFPR Medianeira | Slide 6 de 16</a:t>
+              <a:t>SAREL v2.0 • Sistema de Amostragem e Rotulagem para Erosão Laminar | UTFPR Medianeira | Slide 6 de 17</a:t>
             </a:r>
           </a:p>
         </p:txBody>
@@ -12222,7 +12237,7 @@
               </a:defRPr>
             </a:pPr>
             <a:r>
-              <a:t>SAREL v2.0 • Sistema de Amostragem e Rotulagem para Erosão Laminar | UTFPR Medianeira | Slide 7 de 16</a:t>
+              <a:t>SAREL v2.0 • Sistema de Amostragem e Rotulagem para Erosão Laminar | UTFPR Medianeira | Slide 7 de 17</a:t>
             </a:r>
           </a:p>
         </p:txBody>
@@ -12962,7 +12977,7 @@
               </a:defRPr>
             </a:pPr>
             <a:r>
-              <a:t>SAREL v2.0 • Sistema de Amostragem e Rotulagem para Erosão Laminar | UTFPR Medianeira | Slide 8 de 16</a:t>
+              <a:t>SAREL v2.0 • Sistema de Amostragem e Rotulagem para Erosão Laminar | UTFPR Medianeira | Slide 8 de 17</a:t>
             </a:r>
           </a:p>
         </p:txBody>
@@ -13293,7 +13308,7 @@
               </a:defRPr>
             </a:pPr>
             <a:r>
-              <a:t>• Fase A (PlanetScope 3 m): 2 intérpretes humanos independentes; pares antes/depois de chuva; validação por Kappa de Cohen (k &gt;= 0.60).</a:t>
+              <a:t>• Fase A (PlanetScope 3 m): 2 fotointérpretes humanos independentes; pares antes/depois de chuva; validação por Kappa de Cohen (k &gt;= 0.60).</a:t>
             </a:r>
           </a:p>
           <a:p>
@@ -13308,7 +13323,7 @@
               </a:defRPr>
             </a:pPr>
             <a:r>
-              <a:t>• Fase B (Auditoria em Campo): Coleta padronizada via formulário KoboToolbox com cruzamento cadastral fundiário (SIGEF, SICAR, SNCR).</a:t>
+              <a:t>• Fase B (Auditoria em Campo): Ficha KoboToolbox com tolerância geodésica P03 de 15 m nominal (até 25 m sob aviso) e cruzamento fundiário (SICAR/SIGEF).</a:t>
             </a:r>
           </a:p>
           <a:p>
@@ -13323,7 +13338,7 @@
               </a:defRPr>
             </a:pPr>
             <a:r>
-              <a:t>• Fase D (Ortomosaicos de Drone): Resolução de 2 cm/pixel; isolado estritamente como conjunto held-out de teste (nunca entra no treino).</a:t>
+              <a:t>• Fase D (VANT Spectral 2 - Nuvem UAV): Sensor multiespectral 5 bandas (B, G, R, RedEdge, NIR), PPK/RTK e GSD 3 a 7,5 cm em 4 sítios de 10 a 50 ha.</a:t>
             </a:r>
           </a:p>
           <a:p>
@@ -13338,7 +13353,7 @@
               </a:defRPr>
             </a:pPr>
             <a:r>
-              <a:t>• Regra Inviolável 6: Coordenadas geográficas NUNCA entram na matriz de treino tabular, impedindo o aprendizado de viés de localização.</a:t>
+              <a:t>• Confronto Radiométrico: Correlação de Pearson r entre NDVI Sentinel-2 e drone, mantido estritamente como held-out (Regra 4).</a:t>
             </a:r>
           </a:p>
         </p:txBody>
@@ -13559,7 +13574,7 @@
               </a:defRPr>
             </a:pPr>
             <a:r>
-              <a:t>SAREL v2.0 • Sistema de Amostragem e Rotulagem para Erosão Laminar | UTFPR Medianeira | Slide 9 de 16</a:t>
+              <a:t>SAREL v2.0 • Sistema de Amostragem e Rotulagem para Erosão Laminar | UTFPR Medianeira | Slide 9 de 17</a:t>
             </a:r>
           </a:p>
         </p:txBody>

</xml_diff>

<commit_message>
feat(instalador): adicionar executavel unico Instalador_SAREL.exe com integracao ao Google Drive e atualizar manuais/apresentacao
</commit_message>
<xml_diff>
--- a/docs/Apresentacao_SAREL_PPGTCA_2026.pptx
+++ b/docs/Apresentacao_SAREL_PPGTCA_2026.pptx
@@ -22,6 +22,7 @@
     <p:sldId id="270" r:id="rId21"/>
     <p:sldId id="271" r:id="rId22"/>
     <p:sldId id="272" r:id="rId23"/>
+    <p:sldId id="273" r:id="rId24"/>
   </p:sldIdLst>
   <p:sldSz cx="12191695" cy="6858000" type="screen4x3"/>
   <p:notesSz cx="6858000" cy="9144000"/>
@@ -7283,7 +7284,7 @@
               </a:defRPr>
             </a:pPr>
             <a:r>
-              <a:t>15. Referências Bibliográficas (Normas ABNT NBR 6023:2018) — Parte 1</a:t>
+              <a:t>15. Implantação Autônoma (Instalador_SAREL.exe) e Google Drive</a:t>
             </a:r>
           </a:p>
         </p:txBody>
@@ -7363,7 +7364,7 @@
               </a:defRPr>
             </a:pPr>
             <a:r>
-              <a:t>SAREL v2.0 • Sistema de Amostragem e Rotulagem para Erosão Laminar | UTFPR Medianeira | Slide 16 de 17</a:t>
+              <a:t>SAREL v2.0 • Sistema de Amostragem e Rotulagem para Erosão Laminar | UTFPR Medianeira | Slide 16 de 18</a:t>
             </a:r>
           </a:p>
         </p:txBody>
@@ -7387,7 +7388,7 @@
           </a:solidFill>
           <a:ln>
             <a:solidFill>
-              <a:srgbClr val="E2E8F0"/>
+              <a:srgbClr val="059669"/>
             </a:solidFill>
           </a:ln>
         </p:spPr>
@@ -7421,8 +7422,8 @@
         </p:nvSpPr>
         <p:spPr>
           <a:xfrm>
-            <a:off x="1005840" y="1371600"/>
-            <a:ext cx="10149840" cy="4663440"/>
+            <a:off x="1005840" y="1463040"/>
+            <a:ext cx="10149840" cy="4572000"/>
           </a:xfrm>
           <a:prstGeom prst="rect">
             <a:avLst/>
@@ -7437,106 +7438,93 @@
           <a:p>
             <a:pPr>
               <a:spcAft>
-                <a:spcPts val="1000"/>
+                <a:spcPts val="1200"/>
               </a:spcAft>
-              <a:defRPr sz="1000">
+            </a:pPr>
+            <a:r>
+              <a:rPr b="1" sz="1100">
+                <a:solidFill>
+                  <a:srgbClr val="065F46"/>
+                </a:solidFill>
+              </a:rPr>
+              <a:t>• Executável Único Auto-Suficiente (Instalador_SAREL.exe — 2,0 MB): </a:t>
+            </a:r>
+            <a:r>
+              <a:rPr sz="1050">
                 <a:solidFill>
                   <a:srgbClr val="0F172A"/>
                 </a:solidFill>
-              </a:defRPr>
-            </a:pPr>
-            <a:r>
-              <a:t>• COELHO, M. R. et al. Erodibilidade dos solos do Brasil. Rio de Janeiro: Embrapa Solos, 2024. 38 p. (Documentos / Embrapa Solos, n. 246). Disponível em: http://www.infoteca.cnptia.embrapa.br/infoteca/handle/doc/1170044.</a:t>
+              </a:rPr>
+              <a:t>Desenvolvido em C#/.NET (WinForms) com o código-fonte completo do SAREL embutido (SarelPayload.zip). Permite enviar apenas o arquivo .exe para avaliadores e técnicos que NÃO acessam o GitHub.</a:t>
             </a:r>
           </a:p>
           <a:p>
             <a:pPr>
               <a:spcAft>
-                <a:spcPts val="1000"/>
+                <a:spcPts val="1200"/>
               </a:spcAft>
-              <a:defRPr sz="1000">
+            </a:pPr>
+            <a:r>
+              <a:rPr b="1" sz="1100">
+                <a:solidFill>
+                  <a:srgbClr val="065F46"/>
+                </a:solidFill>
+              </a:rPr>
+              <a:t>• Instalação Automatizada em 1 Clique: </a:t>
+            </a:r>
+            <a:r>
+              <a:rPr sz="1050">
                 <a:solidFill>
                   <a:srgbClr val="0F172A"/>
                 </a:solidFill>
-              </a:defRPr>
-            </a:pPr>
-            <a:r>
-              <a:t>• CHEN, T.; GUESTRIN, C. XGBoost: A Scalable Tree Boosting System. In: ACM SIGKDD INTERNATIONAL CONFERENCE ON KNOWLEDGE DISCOVERY AND DATA MINING, 22., 2016, San Francisco. Proceedings [...]. New York: ACM, 2016. p. 785–794.</a:t>
+              </a:rPr>
+              <a:t>Extrai automaticamente o sistema para C:\SAREL, verifica/instala Node.js e Python silenciosamente via winget/pip/npm e cria atalhos na Área de Trabalho e no Menu Iniciar com o ícone oficial (assets/icon.ico).</a:t>
             </a:r>
           </a:p>
           <a:p>
             <a:pPr>
               <a:spcAft>
-                <a:spcPts val="1000"/>
+                <a:spcPts val="1200"/>
               </a:spcAft>
-              <a:defRPr sz="1000">
+            </a:pPr>
+            <a:r>
+              <a:rPr b="1" sz="1100">
+                <a:solidFill>
+                  <a:srgbClr val="065F46"/>
+                </a:solidFill>
+              </a:rPr>
+              <a:t>• Repositório Oficial no Google Drive: </a:t>
+            </a:r>
+            <a:r>
+              <a:rPr sz="1050">
                 <a:solidFill>
                   <a:srgbClr val="0F172A"/>
                 </a:solidFill>
-              </a:defRPr>
-            </a:pPr>
-            <a:r>
-              <a:t>• DEMATTÊ, J. A. M. et al. Geospatial Soil Sensing System (GEOS3): A powerful data mining procedure to retrieve soil spectral reflectance from satellite images. Remote Sensing of Environment, v. 212, p. 161–175, 2018.</a:t>
+              </a:rPr>
+              <a:t>Integrado diretamente ao diretório https://drive.google.com/drive/folders/1S6UsUYGM3dUh7w_hLrmvcsuh0nSfjyYR?usp=sharing (Dados INCRA, Dados SICAR, Dados SIGEF, Dados SNCR e banco consolidado fundiario_brasil.db com 4,4 milhões de registros).</a:t>
             </a:r>
           </a:p>
           <a:p>
             <a:pPr>
               <a:spcAft>
-                <a:spcPts val="1000"/>
+                <a:spcPts val="1200"/>
               </a:spcAft>
-              <a:defRPr sz="1000">
+            </a:pPr>
+            <a:r>
+              <a:rPr b="1" sz="1100">
+                <a:solidFill>
+                  <a:srgbClr val="065F46"/>
+                </a:solidFill>
+              </a:rPr>
+              <a:t>• Download Automático Pós-Instalação: </a:t>
+            </a:r>
+            <a:r>
+              <a:rPr sz="1050">
                 <a:solidFill>
                   <a:srgbClr val="0F172A"/>
                 </a:solidFill>
-              </a:defRPr>
-            </a:pPr>
-            <a:r>
-              <a:t>• DURIGON, V. L. et al. NDVI-based C-factor estimation for RUSLE in Brazilian watersheds. Revista Brasileira de Ciência do Solo, v. 38, n. 3, p. 726–734, 2014.</a:t>
-            </a:r>
-          </a:p>
-          <a:p>
-            <a:pPr>
-              <a:spcAft>
-                <a:spcPts val="1000"/>
-              </a:spcAft>
-              <a:defRPr sz="1000">
-                <a:solidFill>
-                  <a:srgbClr val="0F172A"/>
-                </a:solidFill>
-              </a:defRPr>
-            </a:pPr>
-            <a:r>
-              <a:t>• KARYDAS, C. G.; PANAGOS, P. The G2 erosion model: month-time step assessments at regional scale. Environmental Research, v. 161, p. 115–124, 2018.</a:t>
-            </a:r>
-          </a:p>
-          <a:p>
-            <a:pPr>
-              <a:spcAft>
-                <a:spcPts val="1000"/>
-              </a:spcAft>
-              <a:defRPr sz="1000">
-                <a:solidFill>
-                  <a:srgbClr val="0F172A"/>
-                </a:solidFill>
-              </a:defRPr>
-            </a:pPr>
-            <a:r>
-              <a:t>• KAUFMAN, S. et al. Leakage in data mining: formulation, detection, and avoidance. ACM Transactions on Knowledge Discovery from Data (TKDD), v. 6, n. 4, p. 1–21, 2012.</a:t>
-            </a:r>
-          </a:p>
-          <a:p>
-            <a:pPr>
-              <a:spcAft>
-                <a:spcPts val="1000"/>
-              </a:spcAft>
-              <a:defRPr sz="1000">
-                <a:solidFill>
-                  <a:srgbClr val="0F172A"/>
-                </a:solidFill>
-              </a:defRPr>
-            </a:pPr>
-            <a:r>
-              <a:t>• LANDIS, J. R.; KOCH, G. G. The measurement of observer agreement for categorical data. Biometrics, v. 33, n. 1, p. 159–174, 1977.</a:t>
+              </a:rPr>
+              <a:t>Possui botão para baixar e descompactar automaticamente o banco de dados do Google Drive para a pasta local data/ com barra de progresso, além de botão direto para abrir a pasta no navegador.</a:t>
             </a:r>
           </a:p>
         </p:txBody>
@@ -7550,6 +7538,400 @@
 </file>
 
 <file path=ppt/slides/slide17.xml><?xml version="1.0" encoding="utf-8"?>
+<p:sld xmlns:a="http://schemas.openxmlformats.org/drawingml/2006/main" xmlns:p="http://schemas.openxmlformats.org/presentationml/2006/main" xmlns:r="http://schemas.openxmlformats.org/officeDocument/2006/relationships">
+  <p:cSld>
+    <p:bg>
+      <p:bgPr>
+        <a:solidFill>
+          <a:srgbClr val="F8FAFC"/>
+        </a:solidFill>
+        <a:effectLst/>
+      </p:bgPr>
+    </p:bg>
+    <p:spTree>
+      <p:nvGrpSpPr>
+        <p:cNvPr id="1" name=""/>
+        <p:cNvGrpSpPr/>
+        <p:nvPr/>
+      </p:nvGrpSpPr>
+      <p:grpSpPr/>
+      <p:sp>
+        <p:nvSpPr>
+          <p:cNvPr id="2" name="Rectangle 1"/>
+          <p:cNvSpPr/>
+          <p:nvPr/>
+        </p:nvSpPr>
+        <p:spPr>
+          <a:xfrm>
+            <a:off x="0" y="0"/>
+            <a:ext cx="12191695" cy="1051560"/>
+          </a:xfrm>
+          <a:prstGeom prst="rect">
+            <a:avLst/>
+          </a:prstGeom>
+          <a:solidFill>
+            <a:srgbClr val="0F172A"/>
+          </a:solidFill>
+          <a:ln>
+            <a:solidFill>
+              <a:srgbClr val="0F172A"/>
+            </a:solidFill>
+          </a:ln>
+        </p:spPr>
+        <p:style>
+          <a:lnRef idx="1">
+            <a:schemeClr val="accent1"/>
+          </a:lnRef>
+          <a:fillRef idx="3">
+            <a:schemeClr val="accent1"/>
+          </a:fillRef>
+          <a:effectRef idx="2">
+            <a:schemeClr val="accent1"/>
+          </a:effectRef>
+          <a:fontRef idx="minor">
+            <a:schemeClr val="lt1"/>
+          </a:fontRef>
+        </p:style>
+        <p:txBody>
+          <a:bodyPr rtlCol="0" anchor="ctr"/>
+          <a:lstStyle/>
+          <a:p>
+            <a:pPr algn="ctr"/>
+          </a:p>
+        </p:txBody>
+      </p:sp>
+      <p:sp>
+        <p:nvSpPr>
+          <p:cNvPr id="3" name="TextBox 2"/>
+          <p:cNvSpPr txBox="1"/>
+          <p:nvPr/>
+        </p:nvSpPr>
+        <p:spPr>
+          <a:xfrm>
+            <a:off x="731520" y="109728"/>
+            <a:ext cx="10698480" cy="274320"/>
+          </a:xfrm>
+          <a:prstGeom prst="rect">
+            <a:avLst/>
+          </a:prstGeom>
+          <a:noFill/>
+        </p:spPr>
+        <p:txBody>
+          <a:bodyPr wrap="none">
+            <a:spAutoFit/>
+          </a:bodyPr>
+          <a:lstStyle/>
+          <a:p>
+            <a:pPr>
+              <a:defRPr sz="950" b="1">
+                <a:solidFill>
+                  <a:srgbClr val="10B981"/>
+                </a:solidFill>
+              </a:defRPr>
+            </a:pPr>
+            <a:r>
+              <a:t>PPGTCA 2026 • PESQUISA DE MESTRADO EM EROSÃO LAMINAR (UTFPR)</a:t>
+            </a:r>
+          </a:p>
+        </p:txBody>
+      </p:sp>
+      <p:sp>
+        <p:nvSpPr>
+          <p:cNvPr id="4" name="TextBox 3"/>
+          <p:cNvSpPr txBox="1"/>
+          <p:nvPr/>
+        </p:nvSpPr>
+        <p:spPr>
+          <a:xfrm>
+            <a:off x="731520" y="365760"/>
+            <a:ext cx="10698480" cy="548640"/>
+          </a:xfrm>
+          <a:prstGeom prst="rect">
+            <a:avLst/>
+          </a:prstGeom>
+          <a:noFill/>
+        </p:spPr>
+        <p:txBody>
+          <a:bodyPr wrap="none">
+            <a:spAutoFit/>
+          </a:bodyPr>
+          <a:lstStyle/>
+          <a:p>
+            <a:pPr>
+              <a:defRPr sz="2000" b="1">
+                <a:solidFill>
+                  <a:srgbClr val="FFFFFF"/>
+                </a:solidFill>
+              </a:defRPr>
+            </a:pPr>
+            <a:r>
+              <a:t>16. Referências Bibliográficas (Normas ABNT NBR 6023:2018) — Parte 1</a:t>
+            </a:r>
+          </a:p>
+        </p:txBody>
+      </p:sp>
+      <p:sp>
+        <p:nvSpPr>
+          <p:cNvPr id="5" name="Rectangle 4"/>
+          <p:cNvSpPr/>
+          <p:nvPr/>
+        </p:nvSpPr>
+        <p:spPr>
+          <a:xfrm>
+            <a:off x="0" y="1033271"/>
+            <a:ext cx="12191695" cy="36576"/>
+          </a:xfrm>
+          <a:prstGeom prst="rect">
+            <a:avLst/>
+          </a:prstGeom>
+          <a:solidFill>
+            <a:srgbClr val="059669"/>
+          </a:solidFill>
+          <a:ln>
+            <a:solidFill>
+              <a:srgbClr val="059669"/>
+            </a:solidFill>
+          </a:ln>
+        </p:spPr>
+        <p:style>
+          <a:lnRef idx="1">
+            <a:schemeClr val="accent1"/>
+          </a:lnRef>
+          <a:fillRef idx="3">
+            <a:schemeClr val="accent1"/>
+          </a:fillRef>
+          <a:effectRef idx="2">
+            <a:schemeClr val="accent1"/>
+          </a:effectRef>
+          <a:fontRef idx="minor">
+            <a:schemeClr val="lt1"/>
+          </a:fontRef>
+        </p:style>
+        <p:txBody>
+          <a:bodyPr rtlCol="0" anchor="ctr"/>
+          <a:lstStyle/>
+          <a:p>
+            <a:pPr algn="ctr"/>
+          </a:p>
+        </p:txBody>
+      </p:sp>
+      <p:sp>
+        <p:nvSpPr>
+          <p:cNvPr id="6" name="TextBox 5"/>
+          <p:cNvSpPr txBox="1"/>
+          <p:nvPr/>
+        </p:nvSpPr>
+        <p:spPr>
+          <a:xfrm>
+            <a:off x="731520" y="6492240"/>
+            <a:ext cx="10728655" cy="274320"/>
+          </a:xfrm>
+          <a:prstGeom prst="rect">
+            <a:avLst/>
+          </a:prstGeom>
+          <a:noFill/>
+        </p:spPr>
+        <p:txBody>
+          <a:bodyPr wrap="none">
+            <a:spAutoFit/>
+          </a:bodyPr>
+          <a:lstStyle/>
+          <a:p>
+            <a:pPr>
+              <a:defRPr sz="850">
+                <a:solidFill>
+                  <a:srgbClr val="475569"/>
+                </a:solidFill>
+              </a:defRPr>
+            </a:pPr>
+            <a:r>
+              <a:t>SAREL v2.0 • Sistema de Amostragem e Rotulagem para Erosão Laminar | UTFPR Medianeira | Slide 17 de 18</a:t>
+            </a:r>
+          </a:p>
+        </p:txBody>
+      </p:sp>
+      <p:sp>
+        <p:nvSpPr>
+          <p:cNvPr id="7" name="Rounded Rectangle 6"/>
+          <p:cNvSpPr/>
+          <p:nvPr/>
+        </p:nvSpPr>
+        <p:spPr>
+          <a:xfrm>
+            <a:off x="731520" y="1280160"/>
+            <a:ext cx="10728655" cy="4937760"/>
+          </a:xfrm>
+          <a:prstGeom prst="roundRect">
+            <a:avLst/>
+          </a:prstGeom>
+          <a:solidFill>
+            <a:srgbClr val="FFFFFF"/>
+          </a:solidFill>
+          <a:ln>
+            <a:solidFill>
+              <a:srgbClr val="E2E8F0"/>
+            </a:solidFill>
+          </a:ln>
+        </p:spPr>
+        <p:style>
+          <a:lnRef idx="1">
+            <a:schemeClr val="accent1"/>
+          </a:lnRef>
+          <a:fillRef idx="3">
+            <a:schemeClr val="accent1"/>
+          </a:fillRef>
+          <a:effectRef idx="2">
+            <a:schemeClr val="accent1"/>
+          </a:effectRef>
+          <a:fontRef idx="minor">
+            <a:schemeClr val="lt1"/>
+          </a:fontRef>
+        </p:style>
+        <p:txBody>
+          <a:bodyPr rtlCol="0" anchor="ctr"/>
+          <a:lstStyle/>
+          <a:p>
+            <a:pPr algn="ctr"/>
+          </a:p>
+        </p:txBody>
+      </p:sp>
+      <p:sp>
+        <p:nvSpPr>
+          <p:cNvPr id="8" name="TextBox 7"/>
+          <p:cNvSpPr txBox="1"/>
+          <p:nvPr/>
+        </p:nvSpPr>
+        <p:spPr>
+          <a:xfrm>
+            <a:off x="1005840" y="1371600"/>
+            <a:ext cx="10149840" cy="4663440"/>
+          </a:xfrm>
+          <a:prstGeom prst="rect">
+            <a:avLst/>
+          </a:prstGeom>
+          <a:noFill/>
+        </p:spPr>
+        <p:txBody>
+          <a:bodyPr wrap="square">
+            <a:spAutoFit/>
+          </a:bodyPr>
+          <a:lstStyle/>
+          <a:p>
+            <a:pPr>
+              <a:spcAft>
+                <a:spcPts val="1000"/>
+              </a:spcAft>
+              <a:defRPr sz="1000">
+                <a:solidFill>
+                  <a:srgbClr val="0F172A"/>
+                </a:solidFill>
+              </a:defRPr>
+            </a:pPr>
+            <a:r>
+              <a:t>• COELHO, M. R. et al. Erodibilidade dos solos do Brasil. Rio de Janeiro: Embrapa Solos, 2024. 38 p. (Documentos / Embrapa Solos, n. 246). Disponível em: http://www.infoteca.cnptia.embrapa.br/infoteca/handle/doc/1170044.</a:t>
+            </a:r>
+          </a:p>
+          <a:p>
+            <a:pPr>
+              <a:spcAft>
+                <a:spcPts val="1000"/>
+              </a:spcAft>
+              <a:defRPr sz="1000">
+                <a:solidFill>
+                  <a:srgbClr val="0F172A"/>
+                </a:solidFill>
+              </a:defRPr>
+            </a:pPr>
+            <a:r>
+              <a:t>• CHEN, T.; GUESTRIN, C. XGBoost: A Scalable Tree Boosting System. In: ACM SIGKDD INTERNATIONAL CONFERENCE ON KNOWLEDGE DISCOVERY AND DATA MINING, 22., 2016, San Francisco. Proceedings [...]. New York: ACM, 2016. p. 785–794.</a:t>
+            </a:r>
+          </a:p>
+          <a:p>
+            <a:pPr>
+              <a:spcAft>
+                <a:spcPts val="1000"/>
+              </a:spcAft>
+              <a:defRPr sz="1000">
+                <a:solidFill>
+                  <a:srgbClr val="0F172A"/>
+                </a:solidFill>
+              </a:defRPr>
+            </a:pPr>
+            <a:r>
+              <a:t>• DEMATTÊ, J. A. M. et al. Geospatial Soil Sensing System (GEOS3): A powerful data mining procedure to retrieve soil spectral reflectance from satellite images. Remote Sensing of Environment, v. 212, p. 161–175, 2018.</a:t>
+            </a:r>
+          </a:p>
+          <a:p>
+            <a:pPr>
+              <a:spcAft>
+                <a:spcPts val="1000"/>
+              </a:spcAft>
+              <a:defRPr sz="1000">
+                <a:solidFill>
+                  <a:srgbClr val="0F172A"/>
+                </a:solidFill>
+              </a:defRPr>
+            </a:pPr>
+            <a:r>
+              <a:t>• DURIGON, V. L. et al. NDVI-based C-factor estimation for RUSLE in Brazilian watersheds. Revista Brasileira de Ciência do Solo, v. 38, n. 3, p. 726–734, 2014.</a:t>
+            </a:r>
+          </a:p>
+          <a:p>
+            <a:pPr>
+              <a:spcAft>
+                <a:spcPts val="1000"/>
+              </a:spcAft>
+              <a:defRPr sz="1000">
+                <a:solidFill>
+                  <a:srgbClr val="0F172A"/>
+                </a:solidFill>
+              </a:defRPr>
+            </a:pPr>
+            <a:r>
+              <a:t>• KARYDAS, C. G.; PANAGOS, P. The G2 erosion model: month-time step assessments at regional scale. Environmental Research, v. 161, p. 115–124, 2018.</a:t>
+            </a:r>
+          </a:p>
+          <a:p>
+            <a:pPr>
+              <a:spcAft>
+                <a:spcPts val="1000"/>
+              </a:spcAft>
+              <a:defRPr sz="1000">
+                <a:solidFill>
+                  <a:srgbClr val="0F172A"/>
+                </a:solidFill>
+              </a:defRPr>
+            </a:pPr>
+            <a:r>
+              <a:t>• KAUFMAN, S. et al. Leakage in data mining: formulation, detection, and avoidance. ACM Transactions on Knowledge Discovery from Data (TKDD), v. 6, n. 4, p. 1–21, 2012.</a:t>
+            </a:r>
+          </a:p>
+          <a:p>
+            <a:pPr>
+              <a:spcAft>
+                <a:spcPts val="1000"/>
+              </a:spcAft>
+              <a:defRPr sz="1000">
+                <a:solidFill>
+                  <a:srgbClr val="0F172A"/>
+                </a:solidFill>
+              </a:defRPr>
+            </a:pPr>
+            <a:r>
+              <a:t>• LANDIS, J. R.; KOCH, G. G. The measurement of observer agreement for categorical data. Biometrics, v. 33, n. 1, p. 159–174, 1977.</a:t>
+            </a:r>
+          </a:p>
+        </p:txBody>
+      </p:sp>
+    </p:spTree>
+  </p:cSld>
+  <p:clrMapOvr>
+    <a:masterClrMapping/>
+  </p:clrMapOvr>
+</p:sld>
+</file>
+
+<file path=ppt/slides/slide18.xml><?xml version="1.0" encoding="utf-8"?>
 <p:sld xmlns:a="http://schemas.openxmlformats.org/drawingml/2006/main" xmlns:p="http://schemas.openxmlformats.org/presentationml/2006/main" xmlns:r="http://schemas.openxmlformats.org/officeDocument/2006/relationships">
   <p:cSld>
     <p:bg>

</xml_diff>